<commit_message>
E5: integra el trabajo de Codex en el informe y la presentación
- Prototipo con métricas del Ridge en la portada y capturas nuevas
- Sección 5.6 y figura del flujo de trabajo con GitHub y dos agentes
- Anexo H con el registro de modelos y Anexo K de trazabilidad
- Diapositiva nueva sobre cómo se construyó el proyecto

Co-Authored-By: Claude Opus 5.5 <noreply@anthropic.com>
Claude-Session: https://claude.ai/code/session_01Sm1GEyEEaRYCzcLRpQWvbd
</commit_message>
<xml_diff>
--- a/entrega5/TIG_IA_Grupo01_LumineMotors_Presentacion.pptx
+++ b/entrega5/TIG_IA_Grupo01_LumineMotors_Presentacion.pptx
@@ -15,9 +15,10 @@
     <p:sldId id="263" r:id="rId9"/>
     <p:sldId id="264" r:id="rId10"/>
     <p:sldId id="265" r:id="rId11"/>
+    <p:sldId id="266" r:id="rId12"/>
   </p:sldIdLst>
   <p:notesMasterIdLst>
-    <p:notesMasterId r:id="rId12"/>
+    <p:notesMasterId r:id="rId13"/>
   </p:notesMasterIdLst>
   <p:sldSz cx="12192000" cy="6858000"/>
   <p:notesSz cx="6858000" cy="12192000"/>
@@ -116,30 +117,31 @@
   <p:extLst>
     <p:ext uri="{521415D9-36F7-43E2-AB2F-B90AF26B5E84}">
       <p14:sectionLst xmlns:p14="http://schemas.microsoft.com/office/powerpoint/2010/main">
-        <p14:section name="Problema" id="{dcee6055-810d-b735-75b9-77c7d16002c3}">
+        <p14:section name="Problema" id="{394fcd9b-4ca2-c090-062b-6d8a6730b452}">
           <p14:sldIdLst>
             <p14:sldId id="256"/>
             <p14:sldId id="257"/>
             <p14:sldId id="258"/>
           </p14:sldIdLst>
         </p14:section>
-        <p14:section name="Herramienta" id="{3a05fd6c-f6db-da3f-7769-6fd0d42cbb24}">
+        <p14:section name="Herramienta" id="{f750f563-c363-2a1c-8de3-0480d5dfc052}">
           <p14:sldIdLst>
             <p14:sldId id="259"/>
             <p14:sldId id="260"/>
           </p14:sldIdLst>
         </p14:section>
-        <p14:section name="Resultados" id="{6dd79aa6-dc10-8ccd-9a27-a240d91be81b}">
+        <p14:section name="Resultados" id="{079c144b-93ef-4c1d-7110-7a8b07aca66d}">
           <p14:sldIdLst>
             <p14:sldId id="261"/>
             <p14:sldId id="262"/>
+            <p14:sldId id="263"/>
           </p14:sldIdLst>
         </p14:section>
-        <p14:section name="Implementación" id="{84dcf022-2d1a-bcae-6c2b-971b511adafe}">
+        <p14:section name="Implementación" id="{eaea1c3c-2bbd-2b41-d56a-4d0f3ee27a09}">
           <p14:sldIdLst>
-            <p14:sldId id="263"/>
             <p14:sldId id="264"/>
             <p14:sldId id="265"/>
+            <p14:sldId id="266"/>
           </p14:sldIdLst>
         </p14:section>
       </p14:sectionLst>
@@ -1269,7 +1271,7 @@
           <a:p>
             <a:r>
               <a:rPr lang="en-US" dirty="0"/>
-              <a:t>DIEGO (35 s). Nuestra respuesta es sí, con una condición. La IA estima el ahorro de cada cliente diez veces mejor que la cifra genérica y lo comunica sin inventar, pero el intervalo solo es confiable después de recalibrarlo con datos reales. Recomendamos implementar con ajustes: retirar hoy el “hasta 25%”, medir con un A/B y habilitar el diagnóstico cuando la telemetría lo confirme. Los límites son claros: ahorro simulado, datos reales secundarios y el efecto en el cliente por medir. Gracias.</a:t>
+              <a:t>LUKAS (40 s). La implementación va por fases y cada una termina en una decisión. Primero, cambiar ya el “hasta 25%” por la cotización con intervalo. Luego, un piloto A/B que mida si la estimación personal aumenta el agendamiento, y diez instalaciones con telemetría para recalibrar. El estimador cuesta unos 9 millones el primer año y se paga si sube el agendamiento en 3 puntos; con 5 puntos, el retorno es de 68%. Si no cambia nada, se pierde el costo: por eso el A/B va primero.</a:t>
             </a:r>
             <a:endParaRPr lang="en-US" dirty="0"/>
           </a:p>
@@ -1293,6 +1295,94 @@
             <a:fld id="{F7021451-1387-4CA6-816F-3879F97B5CBC}" type="slidenum">
               <a:rPr lang="en-US"/>
               <a:t>10</a:t>
+            </a:fld>
+            <a:endParaRPr lang="en-US"/>
+          </a:p>
+        </p:txBody>
+      </p:sp>
+    </p:spTree>
+    <p:extLst>
+      <p:ext uri="{BB962C8B-B14F-4D97-AF65-F5344CB8AC3E}">
+        <p14:creationId xmlns:p14="http://schemas.microsoft.com/office/powerpoint/2010/main" val="1024086991"/>
+      </p:ext>
+    </p:extLst>
+  </p:cSld>
+  <p:clrMapOvr>
+    <a:masterClrMapping/>
+  </p:clrMapOvr>
+</p:notes>
+</file>
+
+<file path=ppt/notesSlides/notesSlide11.xml><?xml version="1.0" encoding="utf-8"?>
+<p:notes xmlns:a="http://schemas.openxmlformats.org/drawingml/2006/main" xmlns:r="http://schemas.openxmlformats.org/officeDocument/2006/relationships" xmlns:p="http://schemas.openxmlformats.org/presentationml/2006/main">
+  <p:cSld>
+    <p:spTree>
+      <p:nvGrpSpPr>
+        <p:cNvPr id="1" name=""/>
+        <p:cNvGrpSpPr/>
+        <p:nvPr/>
+      </p:nvGrpSpPr>
+      <p:grpSpPr>
+        <a:xfrm>
+          <a:off x="0" y="0"/>
+          <a:ext cx="0" cy="0"/>
+          <a:chOff x="0" y="0"/>
+          <a:chExt cx="0" cy="0"/>
+        </a:xfrm>
+      </p:grpSpPr>
+      <p:sp>
+        <p:nvSpPr>
+          <p:cNvPr id="2" name="Slide Image Placeholder 1"/>
+          <p:cNvSpPr>
+            <a:spLocks noGrp="1" noRot="1" noChangeAspect="1"/>
+          </p:cNvSpPr>
+          <p:nvPr>
+            <p:ph type="sldImg"/>
+          </p:nvPr>
+        </p:nvSpPr>
+        <p:spPr/>
+      </p:sp>
+      <p:sp>
+        <p:nvSpPr>
+          <p:cNvPr id="3" name="Notes Placeholder 2"/>
+          <p:cNvSpPr>
+            <a:spLocks noGrp="1"/>
+          </p:cNvSpPr>
+          <p:nvPr>
+            <p:ph type="body" idx="1"/>
+          </p:nvPr>
+        </p:nvSpPr>
+        <p:spPr/>
+        <p:txBody>
+          <a:bodyPr/>
+          <a:lstStyle/>
+          <a:p>
+            <a:r>
+              <a:rPr lang="en-US" dirty="0"/>
+              <a:t>DIEGO (35 s). Nuestra respuesta es sí, con una condición. La IA estima el ahorro de cada cliente diez veces mejor que la cifra genérica y lo comunica sin inventar, pero el intervalo solo es confiable después de recalibrarlo con datos reales. Recomendamos implementar con ajustes: retirar hoy el “hasta 25%”, medir con un A/B y habilitar el diagnóstico cuando la telemetría lo confirme. Los límites son claros: ahorro simulado, datos reales secundarios y el efecto en el cliente por medir. Gracias.</a:t>
+            </a:r>
+            <a:endParaRPr lang="en-US" dirty="0"/>
+          </a:p>
+        </p:txBody>
+      </p:sp>
+      <p:sp>
+        <p:nvSpPr>
+          <p:cNvPr id="4" name="Slide Number Placeholder 3"/>
+          <p:cNvSpPr>
+            <a:spLocks noGrp="1"/>
+          </p:cNvSpPr>
+          <p:nvPr>
+            <p:ph type="sldNum" sz="quarter" idx="10"/>
+          </p:nvPr>
+        </p:nvSpPr>
+        <p:spPr/>
+        <p:txBody>
+          <a:bodyPr/>
+          <a:lstStyle/>
+          <a:p>
+            <a:fld id="{F7021451-1387-4CA6-816F-3879F97B5CBC}" type="slidenum">
+              <a:rPr lang="en-US"/>
+              <a:t>11</a:t>
             </a:fld>
             <a:endParaRPr lang="en-US"/>
           </a:p>
@@ -1357,7 +1447,7 @@
           <a:p>
             <a:r>
               <a:rPr lang="en-US" dirty="0"/>
-              <a:t>DIEGO (45 s). El problema es la promesa. El sector vende “hasta 25% de ahorro”, pero el ahorro del kit depende de cuánta energía termina en los frenos, y eso cambia con cada conductor. Al comparar esa cifra con el ahorro simulado de 300 conductores de Santiago, se equivoca en promedio por casi 8 puntos, y en el 98% de los casos por más de 3. En las entrevistas, la barrera no fue el precio sino la confianza. Lumine debe decidir si reemplaza esa cifra por una estimación personal y verificable.</a:t>
+              <a:t>DIEGO (40 s). El problema es la promesa. El sector vende “hasta 25% de ahorro”, pero el ahorro del kit depende de cuánta energía termina en los frenos, y eso cambia con cada conductor. Al comparar esa cifra con el ahorro simulado de 300 conductores de Santiago, se equivoca en promedio por casi 8 puntos, y en el 98% de los casos por más de 3. En las entrevistas, la barrera no fue el precio sino la confianza. Lumine debe decidir si reemplaza esa cifra por una estimación personal y verificable.</a:t>
             </a:r>
             <a:endParaRPr lang="en-US" dirty="0"/>
           </a:p>
@@ -1621,7 +1711,7 @@
           <a:p>
             <a:r>
               <a:rPr lang="en-US" dirty="0"/>
-              <a:t>BENJAMÍN (40 s). Este es el prototipo funcionando. Un colectivo registra una semana con su celular; el sistema calcula once variables y borra la ruta. El modelo estima 19,6% de ahorro, con un rango de 18,2% a 21%. El motor comercial lo traduce a lo que entiende el cliente: 158 mil pesos al mes y recuperar el kit en 22 meses con el escenario conservador. Claude escribe el mensaje y el validador confirma cada número. Esta es también la conexión entre el modelo matemático y el prompt que nos pidió explicar mejor.</a:t>
+              <a:t>BENJAMÍN (40 s). Este es el prototipo funcionando. Un colectivo registra una semana con su celular; el sistema calcula once variables y borra la ruta. El modelo estima 19,7% de ahorro, con un rango de 18,4% a 21%. El motor comercial lo traduce a lo que entiende el cliente: 159 mil pesos al mes y recuperar el kit en 22 meses con el escenario conservador. Claude escribe el mensaje y el validador confirma cada número. Esta es también la conexión entre el modelo matemático y el prompt que nos pidió explicar mejor.</a:t>
             </a:r>
             <a:endParaRPr lang="en-US" dirty="0"/>
           </a:p>
@@ -1885,7 +1975,7 @@
           <a:p>
             <a:r>
               <a:rPr lang="en-US" dirty="0"/>
-              <a:t>LUKAS (40 s). El uso responsable no es un anexo, está en el diseño. La ubicación revela domicilio y rutinas, así que pedimos consentimiento específico, borramos la ruta y la IA generativa nunca recibe datos personales. Toda cifra lleva su rango y medimos si el intervalo es igual de confiable para todos: hoy no lo es del todo para particulares. Cada decisión tiene un responsable humano, y una regla con cinco gatillos detiene el sistema si la promesa deja de cumplirse.</a:t>
+              <a:t>LUKAS (30 s). Así lo construimos. Dos agentes de programación trabajaron en paralelo sobre el mismo repositorio: Claude Code hizo el simulador, el modelo y los informes; Codex llevó el modelo Ridge al prototipo, escribió 20 pruebas y reprodujo todo desde cero. Nosotros revisamos e integramos cada cambio. Las cinco IA auditoras nunca tocaron el código: sus hallazgos entraron como cambios con fecha y autor. Por eso cada cifra que les mostramos se puede rastrear hasta su script.</a:t>
             </a:r>
             <a:endParaRPr lang="en-US" dirty="0"/>
           </a:p>
@@ -1973,7 +2063,7 @@
           <a:p>
             <a:r>
               <a:rPr lang="en-US" dirty="0"/>
-              <a:t>LUKAS (40 s). La implementación va por fases y cada una termina en una decisión. Primero, cambiar ya el “hasta 25%” por la cotización con intervalo. Luego, un piloto A/B que mida si la estimación personal aumenta el agendamiento, y diez instalaciones con telemetría para recalibrar. El estimador cuesta unos 9 millones el primer año y se paga si sube el agendamiento en 3 puntos; con 5 puntos, el retorno es de 68%. Si no cambia nada, se pierde el costo: por eso el A/B va primero.</a:t>
+              <a:t>LUKAS (40 s). El uso responsable no es un anexo, está en el diseño. La ubicación revela domicilio y rutinas, así que pedimos consentimiento específico, borramos la ruta y la IA generativa nunca recibe datos personales. Toda cifra lleva su rango y medimos si el intervalo es igual de confiable para todos: hoy no lo es del todo para particulares. Cada decisión tiene un responsable humano, y una regla con cinco gatillos detiene el sistema si la promesa deja de cumplirse.</a:t>
             </a:r>
             <a:endParaRPr lang="en-US" dirty="0"/>
           </a:p>
@@ -2950,6 +3040,987 @@
         </p:nvSpPr>
         <p:spPr>
           <a:xfrm>
+            <a:off x="548640" y="320040"/>
+            <a:ext cx="11064240" cy="868680"/>
+          </a:xfrm>
+          <a:prstGeom prst="rect">
+            <a:avLst/>
+          </a:prstGeom>
+          <a:noFill/>
+          <a:ln/>
+        </p:spPr>
+        <p:txBody>
+          <a:bodyPr wrap="square" lIns="0" tIns="0" rIns="0" bIns="0" rtlCol="0" anchor="ctr"/>
+          <a:lstStyle/>
+          <a:p>
+            <a:pPr algn="l" indent="0" marL="0">
+              <a:buNone/>
+            </a:pPr>
+            <a:r>
+              <a:rPr lang="en-US" sz="3000" b="1" dirty="0">
+                <a:solidFill>
+                  <a:schemeClr val="tx2"/>
+                </a:solidFill>
+              </a:rPr>
+              <a:t>Implementar por fases, con una decisión en cada hito</a:t>
+            </a:r>
+            <a:endParaRPr lang="en-US" sz="3000" dirty="0"/>
+          </a:p>
+        </p:txBody>
+      </p:sp>
+      <p:sp>
+        <p:nvSpPr>
+          <p:cNvPr id="3" name="Línea de tiempo"/>
+          <p:cNvSpPr/>
+          <p:nvPr/>
+        </p:nvSpPr>
+        <p:spPr>
+          <a:xfrm>
+            <a:off x="868680" y="1783080"/>
+            <a:ext cx="0" cy="3931920"/>
+          </a:xfrm>
+          <a:prstGeom prst="line">
+            <a:avLst/>
+          </a:prstGeom>
+          <a:noFill/>
+          <a:ln w="19050">
+            <a:solidFill>
+              <a:srgbClr val="6B7280"/>
+            </a:solidFill>
+            <a:prstDash val="solid"/>
+          </a:ln>
+        </p:spPr>
+      </p:sp>
+      <p:sp>
+        <p:nvSpPr>
+          <p:cNvPr id="4" name="Fase F0"/>
+          <p:cNvSpPr/>
+          <p:nvPr/>
+        </p:nvSpPr>
+        <p:spPr>
+          <a:xfrm>
+            <a:off x="548640" y="1463040"/>
+            <a:ext cx="640080" cy="640080"/>
+          </a:xfrm>
+          <a:prstGeom prst="ellipse">
+            <a:avLst/>
+          </a:prstGeom>
+          <a:solidFill>
+            <a:srgbClr val="2B4C9B"/>
+          </a:solidFill>
+          <a:ln w="12700">
+            <a:solidFill>
+              <a:srgbClr val="2B4C9B"/>
+            </a:solidFill>
+            <a:prstDash val="solid"/>
+          </a:ln>
+        </p:spPr>
+      </p:sp>
+      <p:sp>
+        <p:nvSpPr>
+          <p:cNvPr id="5" name="Texto fase F0"/>
+          <p:cNvSpPr txBox="1"/>
+          <p:nvPr/>
+        </p:nvSpPr>
+        <p:spPr>
+          <a:xfrm>
+            <a:off x="548640" y="1463040"/>
+            <a:ext cx="640080" cy="640080"/>
+          </a:xfrm>
+          <a:prstGeom prst="rect">
+            <a:avLst/>
+          </a:prstGeom>
+          <a:noFill/>
+          <a:ln/>
+        </p:spPr>
+        <p:txBody>
+          <a:bodyPr wrap="square" lIns="0" tIns="0" rIns="0" bIns="0" rtlCol="0" anchor="ctr"/>
+          <a:lstStyle/>
+          <a:p>
+            <a:pPr algn="ctr" indent="0" marL="0">
+              <a:buNone/>
+            </a:pPr>
+            <a:r>
+              <a:rPr lang="en-US" sz="1500" b="1" dirty="0">
+                <a:solidFill>
+                  <a:schemeClr val="bg1"/>
+                </a:solidFill>
+              </a:rPr>
+              <a:t>F0</a:t>
+            </a:r>
+            <a:endParaRPr lang="en-US" sz="1500" dirty="0"/>
+          </a:p>
+        </p:txBody>
+      </p:sp>
+      <p:sp>
+        <p:nvSpPr>
+          <p:cNvPr id="6" name="Plazo F0"/>
+          <p:cNvSpPr txBox="1"/>
+          <p:nvPr/>
+        </p:nvSpPr>
+        <p:spPr>
+          <a:xfrm>
+            <a:off x="1417320" y="1444752"/>
+            <a:ext cx="5120640" cy="347472"/>
+          </a:xfrm>
+          <a:prstGeom prst="rect">
+            <a:avLst/>
+          </a:prstGeom>
+          <a:noFill/>
+          <a:ln/>
+        </p:spPr>
+        <p:txBody>
+          <a:bodyPr wrap="square" lIns="0" tIns="0" rIns="0" bIns="0" rtlCol="0" anchor="t"/>
+          <a:lstStyle/>
+          <a:p>
+            <a:pPr indent="0" marL="0">
+              <a:buNone/>
+            </a:pPr>
+            <a:r>
+              <a:rPr lang="en-US" sz="1500" b="1" dirty="0">
+                <a:solidFill>
+                  <a:schemeClr val="accent2"/>
+                </a:solidFill>
+              </a:rPr>
+              <a:t>Meses 0 a 1,5</a:t>
+            </a:r>
+            <a:endParaRPr lang="en-US" sz="1500" dirty="0"/>
+          </a:p>
+        </p:txBody>
+      </p:sp>
+      <p:sp>
+        <p:nvSpPr>
+          <p:cNvPr id="7" name="Hito F0"/>
+          <p:cNvSpPr txBox="1"/>
+          <p:nvPr/>
+        </p:nvSpPr>
+        <p:spPr>
+          <a:xfrm>
+            <a:off x="1417320" y="1792224"/>
+            <a:ext cx="5120640" cy="685800"/>
+          </a:xfrm>
+          <a:prstGeom prst="rect">
+            <a:avLst/>
+          </a:prstGeom>
+          <a:noFill/>
+          <a:ln/>
+        </p:spPr>
+        <p:txBody>
+          <a:bodyPr wrap="square" lIns="0" tIns="0" rIns="0" bIns="0" rtlCol="0" anchor="t"/>
+          <a:lstStyle/>
+          <a:p>
+            <a:pPr indent="0" marL="0">
+              <a:buNone/>
+            </a:pPr>
+            <a:r>
+              <a:rPr lang="en-US" sz="1400" dirty="0">
+                <a:solidFill>
+                  <a:schemeClr val="tx2"/>
+                </a:solidFill>
+              </a:rPr>
+              <a:t>Consentimiento y cotización con intervalo en el sitio, en lugar de “hasta 25%”</a:t>
+            </a:r>
+            <a:endParaRPr lang="en-US" sz="1400" dirty="0"/>
+          </a:p>
+        </p:txBody>
+      </p:sp>
+      <p:sp>
+        <p:nvSpPr>
+          <p:cNvPr id="8" name="Fase F1"/>
+          <p:cNvSpPr/>
+          <p:nvPr/>
+        </p:nvSpPr>
+        <p:spPr>
+          <a:xfrm>
+            <a:off x="548640" y="2651760"/>
+            <a:ext cx="640080" cy="640080"/>
+          </a:xfrm>
+          <a:prstGeom prst="ellipse">
+            <a:avLst/>
+          </a:prstGeom>
+          <a:solidFill>
+            <a:srgbClr val="2B4C9B"/>
+          </a:solidFill>
+          <a:ln w="12700">
+            <a:solidFill>
+              <a:srgbClr val="2B4C9B"/>
+            </a:solidFill>
+            <a:prstDash val="solid"/>
+          </a:ln>
+        </p:spPr>
+      </p:sp>
+      <p:sp>
+        <p:nvSpPr>
+          <p:cNvPr id="9" name="Texto fase F1"/>
+          <p:cNvSpPr txBox="1"/>
+          <p:nvPr/>
+        </p:nvSpPr>
+        <p:spPr>
+          <a:xfrm>
+            <a:off x="548640" y="2651760"/>
+            <a:ext cx="640080" cy="640080"/>
+          </a:xfrm>
+          <a:prstGeom prst="rect">
+            <a:avLst/>
+          </a:prstGeom>
+          <a:noFill/>
+          <a:ln/>
+        </p:spPr>
+        <p:txBody>
+          <a:bodyPr wrap="square" lIns="0" tIns="0" rIns="0" bIns="0" rtlCol="0" anchor="ctr"/>
+          <a:lstStyle/>
+          <a:p>
+            <a:pPr algn="ctr" indent="0" marL="0">
+              <a:buNone/>
+            </a:pPr>
+            <a:r>
+              <a:rPr lang="en-US" sz="1500" b="1" dirty="0">
+                <a:solidFill>
+                  <a:schemeClr val="bg1"/>
+                </a:solidFill>
+              </a:rPr>
+              <a:t>F1</a:t>
+            </a:r>
+            <a:endParaRPr lang="en-US" sz="1500" dirty="0"/>
+          </a:p>
+        </p:txBody>
+      </p:sp>
+      <p:sp>
+        <p:nvSpPr>
+          <p:cNvPr id="10" name="Plazo F1"/>
+          <p:cNvSpPr txBox="1"/>
+          <p:nvPr/>
+        </p:nvSpPr>
+        <p:spPr>
+          <a:xfrm>
+            <a:off x="1417320" y="2633472"/>
+            <a:ext cx="5120640" cy="347472"/>
+          </a:xfrm>
+          <a:prstGeom prst="rect">
+            <a:avLst/>
+          </a:prstGeom>
+          <a:noFill/>
+          <a:ln/>
+        </p:spPr>
+        <p:txBody>
+          <a:bodyPr wrap="square" lIns="0" tIns="0" rIns="0" bIns="0" rtlCol="0" anchor="t"/>
+          <a:lstStyle/>
+          <a:p>
+            <a:pPr indent="0" marL="0">
+              <a:buNone/>
+            </a:pPr>
+            <a:r>
+              <a:rPr lang="en-US" sz="1500" b="1" dirty="0">
+                <a:solidFill>
+                  <a:schemeClr val="accent2"/>
+                </a:solidFill>
+              </a:rPr>
+              <a:t>Meses 1,5 a 4</a:t>
+            </a:r>
+            <a:endParaRPr lang="en-US" sz="1500" dirty="0"/>
+          </a:p>
+        </p:txBody>
+      </p:sp>
+      <p:sp>
+        <p:nvSpPr>
+          <p:cNvPr id="11" name="Hito F1"/>
+          <p:cNvSpPr txBox="1"/>
+          <p:nvPr/>
+        </p:nvSpPr>
+        <p:spPr>
+          <a:xfrm>
+            <a:off x="1417320" y="2980944"/>
+            <a:ext cx="5120640" cy="685800"/>
+          </a:xfrm>
+          <a:prstGeom prst="rect">
+            <a:avLst/>
+          </a:prstGeom>
+          <a:noFill/>
+          <a:ln/>
+        </p:spPr>
+        <p:txBody>
+          <a:bodyPr wrap="square" lIns="0" tIns="0" rIns="0" bIns="0" rtlCol="0" anchor="t"/>
+          <a:lstStyle/>
+          <a:p>
+            <a:pPr indent="0" marL="0">
+              <a:buNone/>
+            </a:pPr>
+            <a:r>
+              <a:rPr lang="en-US" sz="1400" dirty="0">
+                <a:solidFill>
+                  <a:schemeClr val="tx2"/>
+                </a:solidFill>
+              </a:rPr>
+              <a:t>Piloto A/B (173 por grupo) y 10 instalaciones con telemetría</a:t>
+            </a:r>
+            <a:endParaRPr lang="en-US" sz="1400" dirty="0"/>
+          </a:p>
+        </p:txBody>
+      </p:sp>
+      <p:sp>
+        <p:nvSpPr>
+          <p:cNvPr id="12" name="Fase F2"/>
+          <p:cNvSpPr/>
+          <p:nvPr/>
+        </p:nvSpPr>
+        <p:spPr>
+          <a:xfrm>
+            <a:off x="548640" y="3840480"/>
+            <a:ext cx="640080" cy="640080"/>
+          </a:xfrm>
+          <a:prstGeom prst="ellipse">
+            <a:avLst/>
+          </a:prstGeom>
+          <a:solidFill>
+            <a:srgbClr val="2B4C9B"/>
+          </a:solidFill>
+          <a:ln w="12700">
+            <a:solidFill>
+              <a:srgbClr val="2B4C9B"/>
+            </a:solidFill>
+            <a:prstDash val="solid"/>
+          </a:ln>
+        </p:spPr>
+      </p:sp>
+      <p:sp>
+        <p:nvSpPr>
+          <p:cNvPr id="13" name="Texto fase F2"/>
+          <p:cNvSpPr txBox="1"/>
+          <p:nvPr/>
+        </p:nvSpPr>
+        <p:spPr>
+          <a:xfrm>
+            <a:off x="548640" y="3840480"/>
+            <a:ext cx="640080" cy="640080"/>
+          </a:xfrm>
+          <a:prstGeom prst="rect">
+            <a:avLst/>
+          </a:prstGeom>
+          <a:noFill/>
+          <a:ln/>
+        </p:spPr>
+        <p:txBody>
+          <a:bodyPr wrap="square" lIns="0" tIns="0" rIns="0" bIns="0" rtlCol="0" anchor="ctr"/>
+          <a:lstStyle/>
+          <a:p>
+            <a:pPr algn="ctr" indent="0" marL="0">
+              <a:buNone/>
+            </a:pPr>
+            <a:r>
+              <a:rPr lang="en-US" sz="1500" b="1" dirty="0">
+                <a:solidFill>
+                  <a:schemeClr val="bg1"/>
+                </a:solidFill>
+              </a:rPr>
+              <a:t>F2</a:t>
+            </a:r>
+            <a:endParaRPr lang="en-US" sz="1500" dirty="0"/>
+          </a:p>
+        </p:txBody>
+      </p:sp>
+      <p:sp>
+        <p:nvSpPr>
+          <p:cNvPr id="14" name="Plazo F2"/>
+          <p:cNvSpPr txBox="1"/>
+          <p:nvPr/>
+        </p:nvSpPr>
+        <p:spPr>
+          <a:xfrm>
+            <a:off x="1417320" y="3822192"/>
+            <a:ext cx="5120640" cy="347472"/>
+          </a:xfrm>
+          <a:prstGeom prst="rect">
+            <a:avLst/>
+          </a:prstGeom>
+          <a:noFill/>
+          <a:ln/>
+        </p:spPr>
+        <p:txBody>
+          <a:bodyPr wrap="square" lIns="0" tIns="0" rIns="0" bIns="0" rtlCol="0" anchor="t"/>
+          <a:lstStyle/>
+          <a:p>
+            <a:pPr indent="0" marL="0">
+              <a:buNone/>
+            </a:pPr>
+            <a:r>
+              <a:rPr lang="en-US" sz="1500" b="1" dirty="0">
+                <a:solidFill>
+                  <a:schemeClr val="accent2"/>
+                </a:solidFill>
+              </a:rPr>
+              <a:t>Meses 4 a 8</a:t>
+            </a:r>
+            <a:endParaRPr lang="en-US" sz="1500" dirty="0"/>
+          </a:p>
+        </p:txBody>
+      </p:sp>
+      <p:sp>
+        <p:nvSpPr>
+          <p:cNvPr id="15" name="Hito F2"/>
+          <p:cNvSpPr txBox="1"/>
+          <p:nvPr/>
+        </p:nvSpPr>
+        <p:spPr>
+          <a:xfrm>
+            <a:off x="1417320" y="4169664"/>
+            <a:ext cx="5120640" cy="685800"/>
+          </a:xfrm>
+          <a:prstGeom prst="rect">
+            <a:avLst/>
+          </a:prstGeom>
+          <a:noFill/>
+          <a:ln/>
+        </p:spPr>
+        <p:txBody>
+          <a:bodyPr wrap="square" lIns="0" tIns="0" rIns="0" bIns="0" rtlCol="0" anchor="t"/>
+          <a:lstStyle/>
+          <a:p>
+            <a:pPr indent="0" marL="0">
+              <a:buNone/>
+            </a:pPr>
+            <a:r>
+              <a:rPr lang="en-US" sz="1400" dirty="0">
+                <a:solidFill>
+                  <a:schemeClr val="tx2"/>
+                </a:solidFill>
+              </a:rPr>
+              <a:t>Verificación posventa y recalibración con datos de Santiago</a:t>
+            </a:r>
+            <a:endParaRPr lang="en-US" sz="1400" dirty="0"/>
+          </a:p>
+        </p:txBody>
+      </p:sp>
+      <p:sp>
+        <p:nvSpPr>
+          <p:cNvPr id="16" name="Fase F3"/>
+          <p:cNvSpPr/>
+          <p:nvPr/>
+        </p:nvSpPr>
+        <p:spPr>
+          <a:xfrm>
+            <a:off x="548640" y="5029200"/>
+            <a:ext cx="640080" cy="640080"/>
+          </a:xfrm>
+          <a:prstGeom prst="ellipse">
+            <a:avLst/>
+          </a:prstGeom>
+          <a:solidFill>
+            <a:srgbClr val="2B4C9B"/>
+          </a:solidFill>
+          <a:ln w="12700">
+            <a:solidFill>
+              <a:srgbClr val="2B4C9B"/>
+            </a:solidFill>
+            <a:prstDash val="solid"/>
+          </a:ln>
+        </p:spPr>
+      </p:sp>
+      <p:sp>
+        <p:nvSpPr>
+          <p:cNvPr id="17" name="Texto fase F3"/>
+          <p:cNvSpPr txBox="1"/>
+          <p:nvPr/>
+        </p:nvSpPr>
+        <p:spPr>
+          <a:xfrm>
+            <a:off x="548640" y="5029200"/>
+            <a:ext cx="640080" cy="640080"/>
+          </a:xfrm>
+          <a:prstGeom prst="rect">
+            <a:avLst/>
+          </a:prstGeom>
+          <a:noFill/>
+          <a:ln/>
+        </p:spPr>
+        <p:txBody>
+          <a:bodyPr wrap="square" lIns="0" tIns="0" rIns="0" bIns="0" rtlCol="0" anchor="ctr"/>
+          <a:lstStyle/>
+          <a:p>
+            <a:pPr algn="ctr" indent="0" marL="0">
+              <a:buNone/>
+            </a:pPr>
+            <a:r>
+              <a:rPr lang="en-US" sz="1500" b="1" dirty="0">
+                <a:solidFill>
+                  <a:schemeClr val="bg1"/>
+                </a:solidFill>
+              </a:rPr>
+              <a:t>F3</a:t>
+            </a:r>
+            <a:endParaRPr lang="en-US" sz="1500" dirty="0"/>
+          </a:p>
+        </p:txBody>
+      </p:sp>
+      <p:sp>
+        <p:nvSpPr>
+          <p:cNvPr id="18" name="Plazo F3"/>
+          <p:cNvSpPr txBox="1"/>
+          <p:nvPr/>
+        </p:nvSpPr>
+        <p:spPr>
+          <a:xfrm>
+            <a:off x="1417320" y="5010912"/>
+            <a:ext cx="5120640" cy="347472"/>
+          </a:xfrm>
+          <a:prstGeom prst="rect">
+            <a:avLst/>
+          </a:prstGeom>
+          <a:noFill/>
+          <a:ln/>
+        </p:spPr>
+        <p:txBody>
+          <a:bodyPr wrap="square" lIns="0" tIns="0" rIns="0" bIns="0" rtlCol="0" anchor="t"/>
+          <a:lstStyle/>
+          <a:p>
+            <a:pPr indent="0" marL="0">
+              <a:buNone/>
+            </a:pPr>
+            <a:r>
+              <a:rPr lang="en-US" sz="1500" b="1" dirty="0">
+                <a:solidFill>
+                  <a:schemeClr val="accent2"/>
+                </a:solidFill>
+              </a:rPr>
+              <a:t>Meses 8 a 12</a:t>
+            </a:r>
+            <a:endParaRPr lang="en-US" sz="1500" dirty="0"/>
+          </a:p>
+        </p:txBody>
+      </p:sp>
+      <p:sp>
+        <p:nvSpPr>
+          <p:cNvPr id="19" name="Hito F3"/>
+          <p:cNvSpPr txBox="1"/>
+          <p:nvPr/>
+        </p:nvSpPr>
+        <p:spPr>
+          <a:xfrm>
+            <a:off x="1417320" y="5358384"/>
+            <a:ext cx="5120640" cy="685800"/>
+          </a:xfrm>
+          <a:prstGeom prst="rect">
+            <a:avLst/>
+          </a:prstGeom>
+          <a:noFill/>
+          <a:ln/>
+        </p:spPr>
+        <p:txBody>
+          <a:bodyPr wrap="square" lIns="0" tIns="0" rIns="0" bIns="0" rtlCol="0" anchor="t"/>
+          <a:lstStyle/>
+          <a:p>
+            <a:pPr indent="0" marL="0">
+              <a:buNone/>
+            </a:pPr>
+            <a:r>
+              <a:rPr lang="en-US" sz="1400" dirty="0">
+                <a:solidFill>
+                  <a:schemeClr val="tx2"/>
+                </a:solidFill>
+              </a:rPr>
+              <a:t>Diagnóstico comercial si la cobertura real queda entre 75% y 85%</a:t>
+            </a:r>
+            <a:endParaRPr lang="en-US" sz="1400" dirty="0"/>
+          </a:p>
+        </p:txBody>
+      </p:sp>
+      <p:sp>
+        <p:nvSpPr>
+          <p:cNvPr id="20" name="Cifra económica 1"/>
+          <p:cNvSpPr/>
+          <p:nvPr/>
+        </p:nvSpPr>
+        <p:spPr>
+          <a:xfrm>
+            <a:off x="6949440" y="1463040"/>
+            <a:ext cx="4663440" cy="1371600"/>
+          </a:xfrm>
+          <a:prstGeom prst="roundRect">
+            <a:avLst>
+              <a:gd name="adj" fmla="val 8000"/>
+            </a:avLst>
+          </a:prstGeom>
+          <a:solidFill>
+            <a:srgbClr val="EEF3F8"/>
+          </a:solidFill>
+          <a:ln w="12700">
+            <a:solidFill>
+              <a:srgbClr val="EEF3F8"/>
+            </a:solidFill>
+            <a:prstDash val="solid"/>
+          </a:ln>
+          <a:effectLst>
+            <a:outerShdw sx="100000" sy="100000" kx="0" ky="0" algn="bl" rotWithShape="0" blurRad="76200" dist="25400" dir="5400000">
+              <a:srgbClr val="1F2A44">
+                <a:alpha val="12000"/>
+              </a:srgbClr>
+            </a:outerShdw>
+          </a:effectLst>
+        </p:spPr>
+      </p:sp>
+      <p:sp>
+        <p:nvSpPr>
+          <p:cNvPr id="21" name="Valor económico 1"/>
+          <p:cNvSpPr txBox="1"/>
+          <p:nvPr/>
+        </p:nvSpPr>
+        <p:spPr>
+          <a:xfrm>
+            <a:off x="7178040" y="1600200"/>
+            <a:ext cx="4206240" cy="594360"/>
+          </a:xfrm>
+          <a:prstGeom prst="rect">
+            <a:avLst/>
+          </a:prstGeom>
+          <a:noFill/>
+          <a:ln/>
+        </p:spPr>
+        <p:txBody>
+          <a:bodyPr wrap="square" lIns="0" tIns="0" rIns="0" bIns="0" rtlCol="0" anchor="t"/>
+          <a:lstStyle/>
+          <a:p>
+            <a:pPr indent="0" marL="0">
+              <a:buNone/>
+            </a:pPr>
+            <a:r>
+              <a:rPr lang="en-US" sz="3200" b="1" dirty="0">
+                <a:solidFill>
+                  <a:schemeClr val="accent2"/>
+                </a:solidFill>
+              </a:rPr>
+              <a:t>$9,0 M</a:t>
+            </a:r>
+            <a:endParaRPr lang="en-US" sz="3200" dirty="0"/>
+          </a:p>
+        </p:txBody>
+      </p:sp>
+      <p:sp>
+        <p:nvSpPr>
+          <p:cNvPr id="22" name="Etiqueta económica 1"/>
+          <p:cNvSpPr txBox="1"/>
+          <p:nvPr/>
+        </p:nvSpPr>
+        <p:spPr>
+          <a:xfrm>
+            <a:off x="7178040" y="2240280"/>
+            <a:ext cx="4206240" cy="502920"/>
+          </a:xfrm>
+          <a:prstGeom prst="rect">
+            <a:avLst/>
+          </a:prstGeom>
+          <a:noFill/>
+          <a:ln/>
+        </p:spPr>
+        <p:txBody>
+          <a:bodyPr wrap="square" lIns="0" tIns="0" rIns="0" bIns="0" rtlCol="0" anchor="t"/>
+          <a:lstStyle/>
+          <a:p>
+            <a:pPr indent="0" marL="0">
+              <a:buNone/>
+            </a:pPr>
+            <a:r>
+              <a:rPr lang="en-US" sz="1400" dirty="0">
+                <a:solidFill>
+                  <a:schemeClr val="tx2"/>
+                </a:solidFill>
+              </a:rPr>
+              <a:t>costo del estimador el primer año</a:t>
+            </a:r>
+            <a:endParaRPr lang="en-US" sz="1400" dirty="0"/>
+          </a:p>
+        </p:txBody>
+      </p:sp>
+      <p:sp>
+        <p:nvSpPr>
+          <p:cNvPr id="23" name="Cifra económica 2"/>
+          <p:cNvSpPr/>
+          <p:nvPr/>
+        </p:nvSpPr>
+        <p:spPr>
+          <a:xfrm>
+            <a:off x="6949440" y="3035808"/>
+            <a:ext cx="4663440" cy="1371600"/>
+          </a:xfrm>
+          <a:prstGeom prst="roundRect">
+            <a:avLst>
+              <a:gd name="adj" fmla="val 8000"/>
+            </a:avLst>
+          </a:prstGeom>
+          <a:solidFill>
+            <a:srgbClr val="0B1220"/>
+          </a:solidFill>
+          <a:ln w="12700">
+            <a:solidFill>
+              <a:srgbClr val="0B1220"/>
+            </a:solidFill>
+            <a:prstDash val="solid"/>
+          </a:ln>
+          <a:effectLst>
+            <a:outerShdw sx="100000" sy="100000" kx="0" ky="0" algn="bl" rotWithShape="0" blurRad="76200" dist="25400" dir="5400000">
+              <a:srgbClr val="1F2A44">
+                <a:alpha val="12000"/>
+              </a:srgbClr>
+            </a:outerShdw>
+          </a:effectLst>
+        </p:spPr>
+      </p:sp>
+      <p:sp>
+        <p:nvSpPr>
+          <p:cNvPr id="24" name="Valor económico 2"/>
+          <p:cNvSpPr txBox="1"/>
+          <p:nvPr/>
+        </p:nvSpPr>
+        <p:spPr>
+          <a:xfrm>
+            <a:off x="7178040" y="3172968"/>
+            <a:ext cx="4206240" cy="594360"/>
+          </a:xfrm>
+          <a:prstGeom prst="rect">
+            <a:avLst/>
+          </a:prstGeom>
+          <a:noFill/>
+          <a:ln/>
+        </p:spPr>
+        <p:txBody>
+          <a:bodyPr wrap="square" lIns="0" tIns="0" rIns="0" bIns="0" rtlCol="0" anchor="t"/>
+          <a:lstStyle/>
+          <a:p>
+            <a:pPr indent="0" marL="0">
+              <a:buNone/>
+            </a:pPr>
+            <a:r>
+              <a:rPr lang="en-US" sz="3200" b="1" dirty="0">
+                <a:solidFill>
+                  <a:schemeClr val="accent1"/>
+                </a:solidFill>
+              </a:rPr>
+              <a:t>+3,0 pp</a:t>
+            </a:r>
+            <a:endParaRPr lang="en-US" sz="3200" dirty="0"/>
+          </a:p>
+        </p:txBody>
+      </p:sp>
+      <p:sp>
+        <p:nvSpPr>
+          <p:cNvPr id="25" name="Etiqueta económica 2"/>
+          <p:cNvSpPr txBox="1"/>
+          <p:nvPr/>
+        </p:nvSpPr>
+        <p:spPr>
+          <a:xfrm>
+            <a:off x="7178040" y="3813048"/>
+            <a:ext cx="4206240" cy="502920"/>
+          </a:xfrm>
+          <a:prstGeom prst="rect">
+            <a:avLst/>
+          </a:prstGeom>
+          <a:noFill/>
+          <a:ln/>
+        </p:spPr>
+        <p:txBody>
+          <a:bodyPr wrap="square" lIns="0" tIns="0" rIns="0" bIns="0" rtlCol="0" anchor="t"/>
+          <a:lstStyle/>
+          <a:p>
+            <a:pPr indent="0" marL="0">
+              <a:buNone/>
+            </a:pPr>
+            <a:r>
+              <a:rPr lang="en-US" sz="1400" dirty="0">
+                <a:solidFill>
+                  <a:schemeClr val="bg1"/>
+                </a:solidFill>
+              </a:rPr>
+              <a:t>de agendamiento bastan para pagarlo (H3 plantea +15)</a:t>
+            </a:r>
+            <a:endParaRPr lang="en-US" sz="1400" dirty="0"/>
+          </a:p>
+        </p:txBody>
+      </p:sp>
+      <p:sp>
+        <p:nvSpPr>
+          <p:cNvPr id="26" name="Cifra económica 3"/>
+          <p:cNvSpPr/>
+          <p:nvPr/>
+        </p:nvSpPr>
+        <p:spPr>
+          <a:xfrm>
+            <a:off x="6949440" y="4608576"/>
+            <a:ext cx="4663440" cy="1371600"/>
+          </a:xfrm>
+          <a:prstGeom prst="roundRect">
+            <a:avLst>
+              <a:gd name="adj" fmla="val 8000"/>
+            </a:avLst>
+          </a:prstGeom>
+          <a:solidFill>
+            <a:srgbClr val="EEF3F8"/>
+          </a:solidFill>
+          <a:ln w="12700">
+            <a:solidFill>
+              <a:srgbClr val="EEF3F8"/>
+            </a:solidFill>
+            <a:prstDash val="solid"/>
+          </a:ln>
+          <a:effectLst>
+            <a:outerShdw sx="100000" sy="100000" kx="0" ky="0" algn="bl" rotWithShape="0" blurRad="76200" dist="25400" dir="5400000">
+              <a:srgbClr val="1F2A44">
+                <a:alpha val="12000"/>
+              </a:srgbClr>
+            </a:outerShdw>
+          </a:effectLst>
+        </p:spPr>
+      </p:sp>
+      <p:sp>
+        <p:nvSpPr>
+          <p:cNvPr id="27" name="Valor económico 3"/>
+          <p:cNvSpPr txBox="1"/>
+          <p:nvPr/>
+        </p:nvSpPr>
+        <p:spPr>
+          <a:xfrm>
+            <a:off x="7178040" y="4745736"/>
+            <a:ext cx="4206240" cy="594360"/>
+          </a:xfrm>
+          <a:prstGeom prst="rect">
+            <a:avLst/>
+          </a:prstGeom>
+          <a:noFill/>
+          <a:ln/>
+        </p:spPr>
+        <p:txBody>
+          <a:bodyPr wrap="square" lIns="0" tIns="0" rIns="0" bIns="0" rtlCol="0" anchor="t"/>
+          <a:lstStyle/>
+          <a:p>
+            <a:pPr indent="0" marL="0">
+              <a:buNone/>
+            </a:pPr>
+            <a:r>
+              <a:rPr lang="en-US" sz="3200" b="1" dirty="0">
+                <a:solidFill>
+                  <a:schemeClr val="accent2"/>
+                </a:solidFill>
+              </a:rPr>
+              <a:t>68%</a:t>
+            </a:r>
+            <a:endParaRPr lang="en-US" sz="3200" dirty="0"/>
+          </a:p>
+        </p:txBody>
+      </p:sp>
+      <p:sp>
+        <p:nvSpPr>
+          <p:cNvPr id="28" name="Etiqueta económica 3"/>
+          <p:cNvSpPr txBox="1"/>
+          <p:nvPr/>
+        </p:nvSpPr>
+        <p:spPr>
+          <a:xfrm>
+            <a:off x="7178040" y="5385816"/>
+            <a:ext cx="4206240" cy="502920"/>
+          </a:xfrm>
+          <a:prstGeom prst="rect">
+            <a:avLst/>
+          </a:prstGeom>
+          <a:noFill/>
+          <a:ln/>
+        </p:spPr>
+        <p:txBody>
+          <a:bodyPr wrap="square" lIns="0" tIns="0" rIns="0" bIns="0" rtlCol="0" anchor="t"/>
+          <a:lstStyle/>
+          <a:p>
+            <a:pPr indent="0" marL="0">
+              <a:buNone/>
+            </a:pPr>
+            <a:r>
+              <a:rPr lang="en-US" sz="1400" dirty="0">
+                <a:solidFill>
+                  <a:schemeClr val="tx2"/>
+                </a:solidFill>
+              </a:rPr>
+              <a:t>retorno del año 1 con +5 pp (escenario base)</a:t>
+            </a:r>
+            <a:endParaRPr lang="en-US" sz="1400" dirty="0"/>
+          </a:p>
+        </p:txBody>
+      </p:sp>
+      <p:sp>
+        <p:nvSpPr>
+          <p:cNvPr id="25" name="Slide Number Placeholder 0"/>
+          <p:cNvSpPr>
+            <a:spLocks noGrp="1"/>
+          </p:cNvSpPr>
+          <p:nvPr>
+            <p:ph type="sldNum" sz="quarter" idx="4294967295"/>
+          </p:nvPr>
+        </p:nvSpPr>
+        <p:spPr>
+          <a:xfrm>
+            <a:off x="11155680" y="6400800"/>
+            <a:ext cx="457200" cy="274320"/>
+          </a:xfrm>
+          <a:prstGeom prst="rect">
+            <a:avLst/>
+          </a:prstGeom>
+          <a:extLst>
+            <a:ext uri="{C572A759-6A51-4108-AA02-DFA0A04FC94B}">
+              <ma14:wrappingTextBoxFlag xmlns:ma14="http://schemas.microsoft.com/office/mac/drawingml/2011/main" val="0"/>
+            </a:ext>
+          </a:extLst>
+        </p:spPr>
+        <p:txBody>
+          <a:bodyPr/>
+          <a:lstStyle>
+            <a:lvl1pPr>
+              <a:defRPr sz="1000">
+                <a:solidFill>
+                  <a:schemeClr val="accent5"/>
+                </a:solidFill>
+              </a:defRPr>
+            </a:lvl1pPr>
+          </a:lstStyle>
+          <a:p>
+            <a:pPr algn="r"/>
+            <a:fld id="{F7021451-1387-4CA6-816F-3879F97B5CBC}" type="slidenum">
+              <a:rPr b="0" lang="en-US"/>
+              <a:t>10</a:t>
+            </a:fld>
+            <a:endParaRPr lang="en-US"/>
+          </a:p>
+        </p:txBody>
+      </p:sp>
+    </p:spTree>
+  </p:cSld>
+  <p:clrMapOvr>
+    <a:masterClrMapping/>
+  </p:clrMapOvr>
+</p:sld>
+</file>
+
+<file path=ppt/slides/slide11.xml><?xml version="1.0" encoding="utf-8"?>
+<p:sld xmlns:a="http://schemas.openxmlformats.org/drawingml/2006/main" xmlns:r="http://schemas.openxmlformats.org/officeDocument/2006/relationships" xmlns:p="http://schemas.openxmlformats.org/presentationml/2006/main">
+  <p:cSld name="Slide 11">
+    <p:spTree>
+      <p:nvGrpSpPr>
+        <p:cNvPr id="1" name=""/>
+        <p:cNvGrpSpPr/>
+        <p:nvPr/>
+      </p:nvGrpSpPr>
+      <p:grpSpPr>
+        <a:xfrm>
+          <a:off x="0" y="0"/>
+          <a:ext cx="0" cy="0"/>
+          <a:chOff x="0" y="0"/>
+          <a:chExt cx="0" cy="0"/>
+        </a:xfrm>
+      </p:grpSpPr>
+      <p:sp>
+        <p:nvSpPr>
+          <p:cNvPr id="2" name="Text 0"/>
+          <p:cNvSpPr/>
+          <p:nvPr>
+            <p:ph idx="100" type="title" hasCustomPrompt="1"/>
+          </p:nvPr>
+        </p:nvSpPr>
+        <p:spPr>
+          <a:xfrm>
             <a:off x="548640" y="411480"/>
             <a:ext cx="11064240" cy="868680"/>
           </a:xfrm>
@@ -3526,7 +4597,7 @@
             <a:pPr algn="r"/>
             <a:fld id="{F7021451-1387-4CA6-816F-3879F97B5CBC}" type="slidenum">
               <a:rPr b="0" lang="en-US"/>
-              <a:t>10</a:t>
+              <a:t>11</a:t>
             </a:fld>
             <a:endParaRPr lang="en-US"/>
           </a:p>
@@ -6246,7 +7317,7 @@
       </p:sp>
       <p:pic>
         <p:nvPicPr>
-          <p:cNvPr id="3" name="Captura prototipo" descr="Captura del prototipo: diagnóstico de un colectivo con 19,6% de ahorro">    </p:cNvPr>
+          <p:cNvPr id="3" name="Captura prototipo" descr="Captura del prototipo: diagnóstico de un colectivo con 19,7% de ahorro">    </p:cNvPr>
           <p:cNvPicPr>
             <a:picLocks noChangeAspect="1"/>
           </p:cNvPicPr>
@@ -6491,7 +7562,7 @@
                   <a:schemeClr val="tx2"/>
                 </a:solidFill>
               </a:rPr>
-              <a:t>Modelo</a:t>
+              <a:t>Modelo Ridge</a:t>
             </a:r>
             <a:endParaRPr lang="en-US" sz="1700" dirty="0"/>
           </a:p>
@@ -6527,7 +7598,7 @@
                   <a:schemeClr val="tx2"/>
                 </a:solidFill>
               </a:rPr>
-              <a:t>19,6% de ahorro, rango de 18,2% a 21,0%</a:t>
+              <a:t>19,7% de ahorro, rango de 18,4% a 21,0%</a:t>
             </a:r>
             <a:endParaRPr lang="en-US" sz="1500" dirty="0"/>
           </a:p>
@@ -6660,7 +7731,7 @@
                   <a:schemeClr val="tx2"/>
                 </a:solidFill>
               </a:rPr>
-              <a:t>$158.000 al mes; recupera el kit en 22 meses (conservador)</a:t>
+              <a:t>$159.000 al mes; recupera el kit en 22 meses (conservador)</a:t>
             </a:r>
             <a:endParaRPr lang="en-US" sz="1500" dirty="0"/>
           </a:p>
@@ -7932,7 +9003,7 @@
                   <a:schemeClr val="tx2"/>
                 </a:solidFill>
               </a:rPr>
-              <a:t>Ninguna cifra sin intervalo ni decisión sin una persona</a:t>
+              <a:t>Dos agentes en paralelo y todo trazable en GitHub</a:t>
             </a:r>
             <a:endParaRPr lang="en-US" sz="3000" dirty="0"/>
           </a:p>
@@ -7940,18 +9011,18 @@
       </p:sp>
       <p:sp>
         <p:nvSpPr>
-          <p:cNvPr id="3" name="Responsable 1"/>
+          <p:cNvPr id="3" name="Carril 1"/>
           <p:cNvSpPr/>
           <p:nvPr/>
         </p:nvSpPr>
         <p:spPr>
           <a:xfrm>
             <a:off x="548640" y="1463040"/>
-            <a:ext cx="5440680" cy="2148840"/>
+            <a:ext cx="6675120" cy="1371600"/>
           </a:xfrm>
           <a:prstGeom prst="roundRect">
             <a:avLst>
-              <a:gd name="adj" fmla="val 5106"/>
+              <a:gd name="adj" fmla="val 8000"/>
             </a:avLst>
           </a:prstGeom>
           <a:solidFill>
@@ -7974,13 +9045,13 @@
       </p:sp>
       <p:sp>
         <p:nvSpPr>
-          <p:cNvPr id="4" name="Ícono Privacidad fondo"/>
+          <p:cNvPr id="4" name="Ícono Claude Code fondo"/>
           <p:cNvSpPr/>
           <p:nvPr/>
         </p:nvSpPr>
         <p:spPr>
           <a:xfrm>
-            <a:off x="822960" y="1737360"/>
+            <a:off x="777240" y="1764792"/>
             <a:ext cx="777240" cy="777240"/>
           </a:xfrm>
           <a:prstGeom prst="ellipse">
@@ -7999,7 +9070,7 @@
       </p:sp>
       <p:pic>
         <p:nvPicPr>
-          <p:cNvPr id="5" name="Ícono Privacidad" descr="Ícono Privacidad">    </p:cNvPr>
+          <p:cNvPr id="5" name="Ícono Claude Code" descr="Ícono Claude Code">    </p:cNvPr>
           <p:cNvPicPr>
             <a:picLocks noChangeAspect="1"/>
           </p:cNvPicPr>
@@ -8013,7 +9084,7 @@
         </p:blipFill>
         <p:spPr>
           <a:xfrm>
-            <a:off x="1009498" y="1923898"/>
+            <a:off x="963778" y="1951330"/>
             <a:ext cx="404165" cy="404165"/>
           </a:xfrm>
           <a:prstGeom prst="rect">
@@ -8023,14 +9094,14 @@
       </p:pic>
       <p:sp>
         <p:nvSpPr>
-          <p:cNvPr id="6" name="Título Privacidad"/>
+          <p:cNvPr id="6" name="Título Claude Code"/>
           <p:cNvSpPr txBox="1"/>
           <p:nvPr/>
         </p:nvSpPr>
         <p:spPr>
           <a:xfrm>
-            <a:off x="1828800" y="1810512"/>
-            <a:ext cx="3931920" cy="457200"/>
+            <a:off x="1783080" y="1627632"/>
+            <a:ext cx="5212080" cy="384048"/>
           </a:xfrm>
           <a:prstGeom prst="rect">
             <a:avLst/>
@@ -8046,27 +9117,27 @@
               <a:buNone/>
             </a:pPr>
             <a:r>
-              <a:rPr lang="en-US" sz="1800" b="1" dirty="0">
+              <a:rPr lang="en-US" sz="1700" b="1" dirty="0">
                 <a:solidFill>
                   <a:schemeClr val="tx2"/>
                 </a:solidFill>
               </a:rPr>
-              <a:t>Privacidad</a:t>
-            </a:r>
-            <a:endParaRPr lang="en-US" sz="1800" dirty="0"/>
-          </a:p>
-        </p:txBody>
-      </p:sp>
-      <p:sp>
-        <p:nvSpPr>
-          <p:cNvPr id="7" name="Texto Privacidad"/>
+              <a:t>Claude Code</a:t>
+            </a:r>
+            <a:endParaRPr lang="en-US" sz="1700" dirty="0"/>
+          </a:p>
+        </p:txBody>
+      </p:sp>
+      <p:sp>
+        <p:nvSpPr>
+          <p:cNvPr id="7" name="Texto Claude Code"/>
           <p:cNvSpPr txBox="1"/>
           <p:nvPr/>
         </p:nvSpPr>
         <p:spPr>
           <a:xfrm>
-            <a:off x="822960" y="2606040"/>
-            <a:ext cx="4937760" cy="914400"/>
+            <a:off x="1783080" y="2029968"/>
+            <a:ext cx="5212080" cy="731520"/>
           </a:xfrm>
           <a:prstGeom prst="rect">
             <a:avLst/>
@@ -8087,7 +9158,7 @@
                   <a:schemeClr val="tx2"/>
                 </a:solidFill>
               </a:rPr>
-              <a:t>Consentimiento específico; se recortan 300 m por viaje y se borra la ruta (Ley 21.719). Claude nunca ve ubicación ni datos personales</a:t>
+              <a:t>Rama claude/…: simulador, modelo, prototipo e informes. 15 commits; cada cifra sale de un script</a:t>
             </a:r>
             <a:endParaRPr lang="en-US" sz="1400" dirty="0"/>
           </a:p>
@@ -8095,18 +9166,18 @@
       </p:sp>
       <p:sp>
         <p:nvSpPr>
-          <p:cNvPr id="8" name="Responsable 2"/>
+          <p:cNvPr id="8" name="Carril 2"/>
           <p:cNvSpPr/>
           <p:nvPr/>
         </p:nvSpPr>
         <p:spPr>
           <a:xfrm>
-            <a:off x="6172200" y="1463040"/>
-            <a:ext cx="5440680" cy="2148840"/>
+            <a:off x="548640" y="3035808"/>
+            <a:ext cx="6675120" cy="1371600"/>
           </a:xfrm>
           <a:prstGeom prst="roundRect">
             <a:avLst>
-              <a:gd name="adj" fmla="val 5106"/>
+              <a:gd name="adj" fmla="val 8000"/>
             </a:avLst>
           </a:prstGeom>
           <a:solidFill>
@@ -8129,24 +9200,24 @@
       </p:sp>
       <p:sp>
         <p:nvSpPr>
-          <p:cNvPr id="9" name="Ícono Transparencia y equidad fondo"/>
+          <p:cNvPr id="9" name="Ícono Codex fondo"/>
           <p:cNvSpPr/>
           <p:nvPr/>
         </p:nvSpPr>
         <p:spPr>
           <a:xfrm>
-            <a:off x="6446520" y="1737360"/>
+            <a:off x="777240" y="3337560"/>
             <a:ext cx="777240" cy="777240"/>
           </a:xfrm>
           <a:prstGeom prst="ellipse">
             <a:avLst/>
           </a:prstGeom>
           <a:solidFill>
-            <a:srgbClr val="2B4C9B"/>
+            <a:srgbClr val="14A3E0"/>
           </a:solidFill>
           <a:ln w="12700">
             <a:solidFill>
-              <a:srgbClr val="2B4C9B"/>
+              <a:srgbClr val="14A3E0"/>
             </a:solidFill>
             <a:prstDash val="solid"/>
           </a:ln>
@@ -8154,7 +9225,7 @@
       </p:sp>
       <p:pic>
         <p:nvPicPr>
-          <p:cNvPr id="10" name="Ícono Transparencia y equidad" descr="Ícono Transparencia y equidad">    </p:cNvPr>
+          <p:cNvPr id="10" name="Ícono Codex" descr="Ícono Codex">    </p:cNvPr>
           <p:cNvPicPr>
             <a:picLocks noChangeAspect="1"/>
           </p:cNvPicPr>
@@ -8168,7 +9239,7 @@
         </p:blipFill>
         <p:spPr>
           <a:xfrm>
-            <a:off x="6633058" y="1923898"/>
+            <a:off x="963778" y="3524098"/>
             <a:ext cx="404165" cy="404165"/>
           </a:xfrm>
           <a:prstGeom prst="rect">
@@ -8178,14 +9249,14 @@
       </p:pic>
       <p:sp>
         <p:nvSpPr>
-          <p:cNvPr id="11" name="Título Transparencia y equidad"/>
+          <p:cNvPr id="11" name="Título Codex"/>
           <p:cNvSpPr txBox="1"/>
           <p:nvPr/>
         </p:nvSpPr>
         <p:spPr>
           <a:xfrm>
-            <a:off x="7452360" y="1810512"/>
-            <a:ext cx="3931920" cy="457200"/>
+            <a:off x="1783080" y="3200400"/>
+            <a:ext cx="5212080" cy="384048"/>
           </a:xfrm>
           <a:prstGeom prst="rect">
             <a:avLst/>
@@ -8201,27 +9272,27 @@
               <a:buNone/>
             </a:pPr>
             <a:r>
-              <a:rPr lang="en-US" sz="1800" b="1" dirty="0">
+              <a:rPr lang="en-US" sz="1700" b="1" dirty="0">
                 <a:solidFill>
                   <a:schemeClr val="tx2"/>
                 </a:solidFill>
               </a:rPr>
-              <a:t>Transparencia y equidad</a:t>
-            </a:r>
-            <a:endParaRPr lang="en-US" sz="1800" dirty="0"/>
-          </a:p>
-        </p:txBody>
-      </p:sp>
-      <p:sp>
-        <p:nvSpPr>
-          <p:cNvPr id="12" name="Texto Transparencia y equidad"/>
+              <a:t>Codex</a:t>
+            </a:r>
+            <a:endParaRPr lang="en-US" sz="1700" dirty="0"/>
+          </a:p>
+        </p:txBody>
+      </p:sp>
+      <p:sp>
+        <p:nvSpPr>
+          <p:cNvPr id="12" name="Texto Codex"/>
           <p:cNvSpPr txBox="1"/>
           <p:nvPr/>
         </p:nvSpPr>
         <p:spPr>
           <a:xfrm>
-            <a:off x="6446520" y="2606040"/>
-            <a:ext cx="4937760" cy="914400"/>
+            <a:off x="1783080" y="3602736"/>
+            <a:ext cx="5212080" cy="731520"/>
           </a:xfrm>
           <a:prstGeom prst="rect">
             <a:avLst/>
@@ -8242,7 +9313,7 @@
                   <a:schemeClr val="tx2"/>
                 </a:solidFill>
               </a:rPr>
-              <a:t>Toda cifra va con su rango. La cobertura se mide por perfil: 87% en colectivos frente a 77% en particulares</a:t>
+              <a:t>Rama codex/…: Ridge en el prototipo, 20 pruebas, GitHub Actions y reproducción desde cero</a:t>
             </a:r>
             <a:endParaRPr lang="en-US" sz="1400" dirty="0"/>
           </a:p>
@@ -8250,18 +9321,18 @@
       </p:sp>
       <p:sp>
         <p:nvSpPr>
-          <p:cNvPr id="13" name="Responsable 3"/>
+          <p:cNvPr id="13" name="Carril 3"/>
           <p:cNvSpPr/>
           <p:nvPr/>
         </p:nvSpPr>
         <p:spPr>
           <a:xfrm>
-            <a:off x="548640" y="3840480"/>
-            <a:ext cx="5440680" cy="2148840"/>
+            <a:off x="548640" y="4608576"/>
+            <a:ext cx="6675120" cy="1371600"/>
           </a:xfrm>
           <a:prstGeom prst="roundRect">
             <a:avLst>
-              <a:gd name="adj" fmla="val 5106"/>
+              <a:gd name="adj" fmla="val 8000"/>
             </a:avLst>
           </a:prstGeom>
           <a:solidFill>
@@ -8284,24 +9355,24 @@
       </p:sp>
       <p:sp>
         <p:nvSpPr>
-          <p:cNvPr id="14" name="Ícono Gobernanza humana fondo"/>
+          <p:cNvPr id="14" name="Ícono 5 IA auditoras fondo"/>
           <p:cNvSpPr/>
           <p:nvPr/>
         </p:nvSpPr>
         <p:spPr>
           <a:xfrm>
-            <a:off x="822960" y="4114800"/>
+            <a:off x="777240" y="4910328"/>
             <a:ext cx="777240" cy="777240"/>
           </a:xfrm>
           <a:prstGeom prst="ellipse">
             <a:avLst/>
           </a:prstGeom>
           <a:solidFill>
-            <a:srgbClr val="2B4C9B"/>
+            <a:srgbClr val="F59E0B"/>
           </a:solidFill>
           <a:ln w="12700">
             <a:solidFill>
-              <a:srgbClr val="2B4C9B"/>
+              <a:srgbClr val="F59E0B"/>
             </a:solidFill>
             <a:prstDash val="solid"/>
           </a:ln>
@@ -8309,7 +9380,7 @@
       </p:sp>
       <p:pic>
         <p:nvPicPr>
-          <p:cNvPr id="15" name="Ícono Gobernanza humana" descr="Ícono Gobernanza humana">    </p:cNvPr>
+          <p:cNvPr id="15" name="Ícono 5 IA auditoras" descr="Ícono 5 IA auditoras">    </p:cNvPr>
           <p:cNvPicPr>
             <a:picLocks noChangeAspect="1"/>
           </p:cNvPicPr>
@@ -8323,7 +9394,7 @@
         </p:blipFill>
         <p:spPr>
           <a:xfrm>
-            <a:off x="1009498" y="4301338"/>
+            <a:off x="963778" y="5096866"/>
             <a:ext cx="404165" cy="404165"/>
           </a:xfrm>
           <a:prstGeom prst="rect">
@@ -8333,14 +9404,14 @@
       </p:pic>
       <p:sp>
         <p:nvSpPr>
-          <p:cNvPr id="16" name="Título Gobernanza humana"/>
+          <p:cNvPr id="16" name="Título 5 IA auditoras"/>
           <p:cNvSpPr txBox="1"/>
           <p:nvPr/>
         </p:nvSpPr>
         <p:spPr>
           <a:xfrm>
-            <a:off x="1828800" y="4187952"/>
-            <a:ext cx="3931920" cy="457200"/>
+            <a:off x="1783080" y="4773168"/>
+            <a:ext cx="5212080" cy="384048"/>
           </a:xfrm>
           <a:prstGeom prst="rect">
             <a:avLst/>
@@ -8356,27 +9427,27 @@
               <a:buNone/>
             </a:pPr>
             <a:r>
-              <a:rPr lang="en-US" sz="1800" b="1" dirty="0">
+              <a:rPr lang="en-US" sz="1700" b="1" dirty="0">
                 <a:solidFill>
                   <a:schemeClr val="tx2"/>
                 </a:solidFill>
               </a:rPr>
-              <a:t>Gobernanza humana</a:t>
-            </a:r>
-            <a:endParaRPr lang="en-US" sz="1800" dirty="0"/>
-          </a:p>
-        </p:txBody>
-      </p:sp>
-      <p:sp>
-        <p:nvSpPr>
-          <p:cNvPr id="17" name="Texto Gobernanza humana"/>
+              <a:t>5 IA auditoras</a:t>
+            </a:r>
+            <a:endParaRPr lang="en-US" sz="1700" dirty="0"/>
+          </a:p>
+        </p:txBody>
+      </p:sp>
+      <p:sp>
+        <p:nvSpPr>
+          <p:cNvPr id="17" name="Texto 5 IA auditoras"/>
           <p:cNvSpPr txBox="1"/>
           <p:nvPr/>
         </p:nvSpPr>
         <p:spPr>
           <a:xfrm>
-            <a:off x="822960" y="4983480"/>
-            <a:ext cx="4937760" cy="914400"/>
+            <a:off x="1783080" y="5175504"/>
+            <a:ext cx="5212080" cy="731520"/>
           </a:xfrm>
           <a:prstGeom prst="rect">
             <a:avLst/>
@@ -8397,7 +9468,7 @@
                   <a:schemeClr val="tx2"/>
                 </a:solidFill>
               </a:rPr>
-              <a:t>La gerencia aprueba cambios; el técnico supervisa cada caso; la ingeniería recalibra; nadie delega en la IA legalidad ni garantía</a:t>
+              <a:t>Gemini, ChatGPT, DeepSeek, Grok y Canva IA revisan sin tocar el código; sus hallazgos entran como commits</a:t>
             </a:r>
             <a:endParaRPr lang="en-US" sz="1400" dirty="0"/>
           </a:p>
@@ -8405,18 +9476,124 @@
       </p:sp>
       <p:sp>
         <p:nvSpPr>
-          <p:cNvPr id="18" name="Responsable 4"/>
+          <p:cNvPr id="18" name="Cifra GitHub 1"/>
           <p:cNvSpPr/>
           <p:nvPr/>
         </p:nvSpPr>
         <p:spPr>
           <a:xfrm>
-            <a:off x="6172200" y="3840480"/>
-            <a:ext cx="5440680" cy="2148840"/>
+            <a:off x="7589520" y="1463040"/>
+            <a:ext cx="4023360" cy="1371600"/>
           </a:xfrm>
           <a:prstGeom prst="roundRect">
             <a:avLst>
-              <a:gd name="adj" fmla="val 5106"/>
+              <a:gd name="adj" fmla="val 8000"/>
+            </a:avLst>
+          </a:prstGeom>
+          <a:solidFill>
+            <a:srgbClr val="FFFFFF"/>
+          </a:solidFill>
+          <a:ln w="12700">
+            <a:solidFill>
+              <a:srgbClr val="FFFFFF"/>
+            </a:solidFill>
+            <a:prstDash val="solid"/>
+          </a:ln>
+          <a:effectLst>
+            <a:outerShdw sx="100000" sy="100000" kx="0" ky="0" algn="bl" rotWithShape="0" blurRad="76200" dist="25400" dir="5400000">
+              <a:srgbClr val="1F2A44">
+                <a:alpha val="12000"/>
+              </a:srgbClr>
+            </a:outerShdw>
+          </a:effectLst>
+        </p:spPr>
+      </p:sp>
+      <p:sp>
+        <p:nvSpPr>
+          <p:cNvPr id="19" name="Valor GitHub 1"/>
+          <p:cNvSpPr txBox="1"/>
+          <p:nvPr/>
+        </p:nvSpPr>
+        <p:spPr>
+          <a:xfrm>
+            <a:off x="7818120" y="1600200"/>
+            <a:ext cx="3566160" cy="594360"/>
+          </a:xfrm>
+          <a:prstGeom prst="rect">
+            <a:avLst/>
+          </a:prstGeom>
+          <a:noFill/>
+          <a:ln/>
+        </p:spPr>
+        <p:txBody>
+          <a:bodyPr wrap="square" lIns="0" tIns="0" rIns="0" bIns="0" rtlCol="0" anchor="t"/>
+          <a:lstStyle/>
+          <a:p>
+            <a:pPr indent="0" marL="0">
+              <a:buNone/>
+            </a:pPr>
+            <a:r>
+              <a:rPr lang="en-US" sz="3200" b="1" dirty="0">
+                <a:solidFill>
+                  <a:schemeClr val="accent2"/>
+                </a:solidFill>
+              </a:rPr>
+              <a:t>18</a:t>
+            </a:r>
+            <a:endParaRPr lang="en-US" sz="3200" dirty="0"/>
+          </a:p>
+        </p:txBody>
+      </p:sp>
+      <p:sp>
+        <p:nvSpPr>
+          <p:cNvPr id="20" name="Etiqueta GitHub 1"/>
+          <p:cNvSpPr txBox="1"/>
+          <p:nvPr/>
+        </p:nvSpPr>
+        <p:spPr>
+          <a:xfrm>
+            <a:off x="7818120" y="2240280"/>
+            <a:ext cx="3566160" cy="502920"/>
+          </a:xfrm>
+          <a:prstGeom prst="rect">
+            <a:avLst/>
+          </a:prstGeom>
+          <a:noFill/>
+          <a:ln/>
+        </p:spPr>
+        <p:txBody>
+          <a:bodyPr wrap="square" lIns="0" tIns="0" rIns="0" bIns="0" rtlCol="0" anchor="t"/>
+          <a:lstStyle/>
+          <a:p>
+            <a:pPr indent="0" marL="0">
+              <a:buNone/>
+            </a:pPr>
+            <a:r>
+              <a:rPr lang="en-US" sz="1400" dirty="0">
+                <a:solidFill>
+                  <a:schemeClr val="tx2"/>
+                </a:solidFill>
+              </a:rPr>
+              <a:t>commits trazables, del 3 al 27 de octubre</a:t>
+            </a:r>
+            <a:endParaRPr lang="en-US" sz="1400" dirty="0"/>
+          </a:p>
+        </p:txBody>
+      </p:sp>
+      <p:sp>
+        <p:nvSpPr>
+          <p:cNvPr id="21" name="Cifra GitHub 2"/>
+          <p:cNvSpPr/>
+          <p:nvPr/>
+        </p:nvSpPr>
+        <p:spPr>
+          <a:xfrm>
+            <a:off x="7589520" y="3035808"/>
+            <a:ext cx="4023360" cy="1371600"/>
+          </a:xfrm>
+          <a:prstGeom prst="roundRect">
+            <a:avLst>
+              <a:gd name="adj" fmla="val 8000"/>
             </a:avLst>
           </a:prstGeom>
           <a:solidFill>
@@ -8439,63 +9616,120 @@
       </p:sp>
       <p:sp>
         <p:nvSpPr>
-          <p:cNvPr id="19" name="Ícono Regla de suspensión fondo"/>
+          <p:cNvPr id="22" name="Valor GitHub 2"/>
+          <p:cNvSpPr txBox="1"/>
+          <p:nvPr/>
+        </p:nvSpPr>
+        <p:spPr>
+          <a:xfrm>
+            <a:off x="7818120" y="3172968"/>
+            <a:ext cx="3566160" cy="594360"/>
+          </a:xfrm>
+          <a:prstGeom prst="rect">
+            <a:avLst/>
+          </a:prstGeom>
+          <a:noFill/>
+          <a:ln/>
+        </p:spPr>
+        <p:txBody>
+          <a:bodyPr wrap="square" lIns="0" tIns="0" rIns="0" bIns="0" rtlCol="0" anchor="t"/>
+          <a:lstStyle/>
+          <a:p>
+            <a:pPr indent="0" marL="0">
+              <a:buNone/>
+            </a:pPr>
+            <a:r>
+              <a:rPr lang="en-US" sz="3200" b="1" dirty="0">
+                <a:solidFill>
+                  <a:schemeClr val="accent1"/>
+                </a:solidFill>
+              </a:rPr>
+              <a:t>20/20</a:t>
+            </a:r>
+            <a:endParaRPr lang="en-US" sz="3200" dirty="0"/>
+          </a:p>
+        </p:txBody>
+      </p:sp>
+      <p:sp>
+        <p:nvSpPr>
+          <p:cNvPr id="23" name="Etiqueta GitHub 2"/>
+          <p:cNvSpPr txBox="1"/>
+          <p:nvPr/>
+        </p:nvSpPr>
+        <p:spPr>
+          <a:xfrm>
+            <a:off x="7818120" y="3813048"/>
+            <a:ext cx="3566160" cy="502920"/>
+          </a:xfrm>
+          <a:prstGeom prst="rect">
+            <a:avLst/>
+          </a:prstGeom>
+          <a:noFill/>
+          <a:ln/>
+        </p:spPr>
+        <p:txBody>
+          <a:bodyPr wrap="square" lIns="0" tIns="0" rIns="0" bIns="0" rtlCol="0" anchor="t"/>
+          <a:lstStyle/>
+          <a:p>
+            <a:pPr indent="0" marL="0">
+              <a:buNone/>
+            </a:pPr>
+            <a:r>
+              <a:rPr lang="en-US" sz="1400" dirty="0">
+                <a:solidFill>
+                  <a:schemeClr val="bg1"/>
+                </a:solidFill>
+              </a:rPr>
+              <a:t>pruebas automáticas en verde al integrar</a:t>
+            </a:r>
+            <a:endParaRPr lang="en-US" sz="1400" dirty="0"/>
+          </a:p>
+        </p:txBody>
+      </p:sp>
+      <p:sp>
+        <p:nvSpPr>
+          <p:cNvPr id="24" name="Cifra GitHub 3"/>
           <p:cNvSpPr/>
           <p:nvPr/>
         </p:nvSpPr>
         <p:spPr>
           <a:xfrm>
-            <a:off x="6446520" y="4114800"/>
-            <a:ext cx="777240" cy="777240"/>
-          </a:xfrm>
-          <a:prstGeom prst="ellipse">
-            <a:avLst/>
+            <a:off x="7589520" y="4608576"/>
+            <a:ext cx="4023360" cy="1371600"/>
+          </a:xfrm>
+          <a:prstGeom prst="roundRect">
+            <a:avLst>
+              <a:gd name="adj" fmla="val 8000"/>
+            </a:avLst>
           </a:prstGeom>
           <a:solidFill>
-            <a:srgbClr val="C0392B"/>
+            <a:srgbClr val="FFFFFF"/>
           </a:solidFill>
           <a:ln w="12700">
             <a:solidFill>
-              <a:srgbClr val="C0392B"/>
+              <a:srgbClr val="FFFFFF"/>
             </a:solidFill>
             <a:prstDash val="solid"/>
           </a:ln>
-        </p:spPr>
-      </p:sp>
-      <p:pic>
-        <p:nvPicPr>
-          <p:cNvPr id="20" name="Ícono Regla de suspensión" descr="Ícono Regla de suspensión">    </p:cNvPr>
-          <p:cNvPicPr>
-            <a:picLocks noChangeAspect="1"/>
-          </p:cNvPicPr>
-          <p:nvPr/>
-        </p:nvPicPr>
-        <p:blipFill>
-          <a:blip r:embed="rId4"/>
-          <a:stretch>
-            <a:fillRect/>
-          </a:stretch>
-        </p:blipFill>
-        <p:spPr>
-          <a:xfrm>
-            <a:off x="6633058" y="4301338"/>
-            <a:ext cx="404165" cy="404165"/>
-          </a:xfrm>
-          <a:prstGeom prst="rect">
-            <a:avLst/>
-          </a:prstGeom>
-        </p:spPr>
-      </p:pic>
-      <p:sp>
-        <p:nvSpPr>
-          <p:cNvPr id="21" name="Título Regla de suspensión"/>
+          <a:effectLst>
+            <a:outerShdw sx="100000" sy="100000" kx="0" ky="0" algn="bl" rotWithShape="0" blurRad="76200" dist="25400" dir="5400000">
+              <a:srgbClr val="1F2A44">
+                <a:alpha val="12000"/>
+              </a:srgbClr>
+            </a:outerShdw>
+          </a:effectLst>
+        </p:spPr>
+      </p:sp>
+      <p:sp>
+        <p:nvSpPr>
+          <p:cNvPr id="25" name="Valor GitHub 3"/>
           <p:cNvSpPr txBox="1"/>
           <p:nvPr/>
         </p:nvSpPr>
         <p:spPr>
           <a:xfrm>
-            <a:off x="7452360" y="4187952"/>
-            <a:ext cx="3931920" cy="457200"/>
+            <a:off x="7818120" y="4745736"/>
+            <a:ext cx="3566160" cy="594360"/>
           </a:xfrm>
           <a:prstGeom prst="rect">
             <a:avLst/>
@@ -8511,27 +9745,27 @@
               <a:buNone/>
             </a:pPr>
             <a:r>
-              <a:rPr lang="en-US" sz="1800" b="1" dirty="0">
-                <a:solidFill>
-                  <a:schemeClr val="bg1"/>
-                </a:solidFill>
-              </a:rPr>
-              <a:t>Regla de suspensión</a:t>
-            </a:r>
-            <a:endParaRPr lang="en-US" sz="1800" dirty="0"/>
-          </a:p>
-        </p:txBody>
-      </p:sp>
-      <p:sp>
-        <p:nvSpPr>
-          <p:cNvPr id="22" name="Texto Regla de suspensión"/>
+              <a:rPr lang="en-US" sz="3200" b="1" dirty="0">
+                <a:solidFill>
+                  <a:schemeClr val="accent2"/>
+                </a:solidFill>
+              </a:rPr>
+              <a:t>14 min</a:t>
+            </a:r>
+            <a:endParaRPr lang="en-US" sz="3200" dirty="0"/>
+          </a:p>
+        </p:txBody>
+      </p:sp>
+      <p:sp>
+        <p:nvSpPr>
+          <p:cNvPr id="26" name="Etiqueta GitHub 3"/>
           <p:cNvSpPr txBox="1"/>
           <p:nvPr/>
         </p:nvSpPr>
         <p:spPr>
           <a:xfrm>
-            <a:off x="6446520" y="4983480"/>
-            <a:ext cx="4937760" cy="914400"/>
+            <a:off x="7818120" y="5385816"/>
+            <a:ext cx="3566160" cy="502920"/>
           </a:xfrm>
           <a:prstGeom prst="rect">
             <a:avLst/>
@@ -8549,10 +9783,10 @@
             <a:r>
               <a:rPr lang="en-US" sz="1400" dirty="0">
                 <a:solidFill>
-                  <a:schemeClr val="bg2"/>
-                </a:solidFill>
-              </a:rPr>
-              <a:t>Se detiene si el error real supera 3 pp, la cobertura cae bajo 70%, un perfil queda 15 pp atrás, el validador falla o hay un reclamo fundado</a:t>
+                  <a:schemeClr val="tx2"/>
+                </a:solidFill>
+              </a:rPr>
+              <a:t>para regenerar el modelo desde cero, medido por Codex</a:t>
             </a:r>
             <a:endParaRPr lang="en-US" sz="1400" dirty="0"/>
           </a:p>
@@ -8660,7 +9894,7 @@
                   <a:schemeClr val="tx2"/>
                 </a:solidFill>
               </a:rPr>
-              <a:t>Implementar por fases, con una decisión en cada hito</a:t>
+              <a:t>Ninguna cifra sin intervalo ni decisión sin una persona</a:t>
             </a:r>
             <a:endParaRPr lang="en-US" sz="3000" dirty="0"/>
           </a:p>
@@ -8668,573 +9902,18 @@
       </p:sp>
       <p:sp>
         <p:nvSpPr>
-          <p:cNvPr id="3" name="Línea de tiempo"/>
+          <p:cNvPr id="3" name="Responsable 1"/>
           <p:cNvSpPr/>
           <p:nvPr/>
         </p:nvSpPr>
         <p:spPr>
           <a:xfrm>
-            <a:off x="868680" y="1783080"/>
-            <a:ext cx="0" cy="3931920"/>
-          </a:xfrm>
-          <a:prstGeom prst="line">
-            <a:avLst/>
-          </a:prstGeom>
-          <a:noFill/>
-          <a:ln w="19050">
-            <a:solidFill>
-              <a:srgbClr val="6B7280"/>
-            </a:solidFill>
-            <a:prstDash val="solid"/>
-          </a:ln>
-        </p:spPr>
-      </p:sp>
-      <p:sp>
-        <p:nvSpPr>
-          <p:cNvPr id="4" name="Fase F0"/>
-          <p:cNvSpPr/>
-          <p:nvPr/>
-        </p:nvSpPr>
-        <p:spPr>
-          <a:xfrm>
             <a:off x="548640" y="1463040"/>
-            <a:ext cx="640080" cy="640080"/>
-          </a:xfrm>
-          <a:prstGeom prst="ellipse">
-            <a:avLst/>
-          </a:prstGeom>
-          <a:solidFill>
-            <a:srgbClr val="2B4C9B"/>
-          </a:solidFill>
-          <a:ln w="12700">
-            <a:solidFill>
-              <a:srgbClr val="2B4C9B"/>
-            </a:solidFill>
-            <a:prstDash val="solid"/>
-          </a:ln>
-        </p:spPr>
-      </p:sp>
-      <p:sp>
-        <p:nvSpPr>
-          <p:cNvPr id="5" name="Texto fase F0"/>
-          <p:cNvSpPr txBox="1"/>
-          <p:nvPr/>
-        </p:nvSpPr>
-        <p:spPr>
-          <a:xfrm>
-            <a:off x="548640" y="1463040"/>
-            <a:ext cx="640080" cy="640080"/>
-          </a:xfrm>
-          <a:prstGeom prst="rect">
-            <a:avLst/>
-          </a:prstGeom>
-          <a:noFill/>
-          <a:ln/>
-        </p:spPr>
-        <p:txBody>
-          <a:bodyPr wrap="square" lIns="0" tIns="0" rIns="0" bIns="0" rtlCol="0" anchor="ctr"/>
-          <a:lstStyle/>
-          <a:p>
-            <a:pPr algn="ctr" indent="0" marL="0">
-              <a:buNone/>
-            </a:pPr>
-            <a:r>
-              <a:rPr lang="en-US" sz="1500" b="1" dirty="0">
-                <a:solidFill>
-                  <a:schemeClr val="bg1"/>
-                </a:solidFill>
-              </a:rPr>
-              <a:t>F0</a:t>
-            </a:r>
-            <a:endParaRPr lang="en-US" sz="1500" dirty="0"/>
-          </a:p>
-        </p:txBody>
-      </p:sp>
-      <p:sp>
-        <p:nvSpPr>
-          <p:cNvPr id="6" name="Plazo F0"/>
-          <p:cNvSpPr txBox="1"/>
-          <p:nvPr/>
-        </p:nvSpPr>
-        <p:spPr>
-          <a:xfrm>
-            <a:off x="1417320" y="1444752"/>
-            <a:ext cx="5120640" cy="347472"/>
-          </a:xfrm>
-          <a:prstGeom prst="rect">
-            <a:avLst/>
-          </a:prstGeom>
-          <a:noFill/>
-          <a:ln/>
-        </p:spPr>
-        <p:txBody>
-          <a:bodyPr wrap="square" lIns="0" tIns="0" rIns="0" bIns="0" rtlCol="0" anchor="t"/>
-          <a:lstStyle/>
-          <a:p>
-            <a:pPr indent="0" marL="0">
-              <a:buNone/>
-            </a:pPr>
-            <a:r>
-              <a:rPr lang="en-US" sz="1500" b="1" dirty="0">
-                <a:solidFill>
-                  <a:schemeClr val="accent2"/>
-                </a:solidFill>
-              </a:rPr>
-              <a:t>Meses 0 a 1,5</a:t>
-            </a:r>
-            <a:endParaRPr lang="en-US" sz="1500" dirty="0"/>
-          </a:p>
-        </p:txBody>
-      </p:sp>
-      <p:sp>
-        <p:nvSpPr>
-          <p:cNvPr id="7" name="Hito F0"/>
-          <p:cNvSpPr txBox="1"/>
-          <p:nvPr/>
-        </p:nvSpPr>
-        <p:spPr>
-          <a:xfrm>
-            <a:off x="1417320" y="1792224"/>
-            <a:ext cx="5120640" cy="685800"/>
-          </a:xfrm>
-          <a:prstGeom prst="rect">
-            <a:avLst/>
-          </a:prstGeom>
-          <a:noFill/>
-          <a:ln/>
-        </p:spPr>
-        <p:txBody>
-          <a:bodyPr wrap="square" lIns="0" tIns="0" rIns="0" bIns="0" rtlCol="0" anchor="t"/>
-          <a:lstStyle/>
-          <a:p>
-            <a:pPr indent="0" marL="0">
-              <a:buNone/>
-            </a:pPr>
-            <a:r>
-              <a:rPr lang="en-US" sz="1400" dirty="0">
-                <a:solidFill>
-                  <a:schemeClr val="tx2"/>
-                </a:solidFill>
-              </a:rPr>
-              <a:t>Consentimiento y cotización con intervalo en el sitio, en lugar de “hasta 25%”</a:t>
-            </a:r>
-            <a:endParaRPr lang="en-US" sz="1400" dirty="0"/>
-          </a:p>
-        </p:txBody>
-      </p:sp>
-      <p:sp>
-        <p:nvSpPr>
-          <p:cNvPr id="8" name="Fase F1"/>
-          <p:cNvSpPr/>
-          <p:nvPr/>
-        </p:nvSpPr>
-        <p:spPr>
-          <a:xfrm>
-            <a:off x="548640" y="2651760"/>
-            <a:ext cx="640080" cy="640080"/>
-          </a:xfrm>
-          <a:prstGeom prst="ellipse">
-            <a:avLst/>
-          </a:prstGeom>
-          <a:solidFill>
-            <a:srgbClr val="2B4C9B"/>
-          </a:solidFill>
-          <a:ln w="12700">
-            <a:solidFill>
-              <a:srgbClr val="2B4C9B"/>
-            </a:solidFill>
-            <a:prstDash val="solid"/>
-          </a:ln>
-        </p:spPr>
-      </p:sp>
-      <p:sp>
-        <p:nvSpPr>
-          <p:cNvPr id="9" name="Texto fase F1"/>
-          <p:cNvSpPr txBox="1"/>
-          <p:nvPr/>
-        </p:nvSpPr>
-        <p:spPr>
-          <a:xfrm>
-            <a:off x="548640" y="2651760"/>
-            <a:ext cx="640080" cy="640080"/>
-          </a:xfrm>
-          <a:prstGeom prst="rect">
-            <a:avLst/>
-          </a:prstGeom>
-          <a:noFill/>
-          <a:ln/>
-        </p:spPr>
-        <p:txBody>
-          <a:bodyPr wrap="square" lIns="0" tIns="0" rIns="0" bIns="0" rtlCol="0" anchor="ctr"/>
-          <a:lstStyle/>
-          <a:p>
-            <a:pPr algn="ctr" indent="0" marL="0">
-              <a:buNone/>
-            </a:pPr>
-            <a:r>
-              <a:rPr lang="en-US" sz="1500" b="1" dirty="0">
-                <a:solidFill>
-                  <a:schemeClr val="bg1"/>
-                </a:solidFill>
-              </a:rPr>
-              <a:t>F1</a:t>
-            </a:r>
-            <a:endParaRPr lang="en-US" sz="1500" dirty="0"/>
-          </a:p>
-        </p:txBody>
-      </p:sp>
-      <p:sp>
-        <p:nvSpPr>
-          <p:cNvPr id="10" name="Plazo F1"/>
-          <p:cNvSpPr txBox="1"/>
-          <p:nvPr/>
-        </p:nvSpPr>
-        <p:spPr>
-          <a:xfrm>
-            <a:off x="1417320" y="2633472"/>
-            <a:ext cx="5120640" cy="347472"/>
-          </a:xfrm>
-          <a:prstGeom prst="rect">
-            <a:avLst/>
-          </a:prstGeom>
-          <a:noFill/>
-          <a:ln/>
-        </p:spPr>
-        <p:txBody>
-          <a:bodyPr wrap="square" lIns="0" tIns="0" rIns="0" bIns="0" rtlCol="0" anchor="t"/>
-          <a:lstStyle/>
-          <a:p>
-            <a:pPr indent="0" marL="0">
-              <a:buNone/>
-            </a:pPr>
-            <a:r>
-              <a:rPr lang="en-US" sz="1500" b="1" dirty="0">
-                <a:solidFill>
-                  <a:schemeClr val="accent2"/>
-                </a:solidFill>
-              </a:rPr>
-              <a:t>Meses 1,5 a 4</a:t>
-            </a:r>
-            <a:endParaRPr lang="en-US" sz="1500" dirty="0"/>
-          </a:p>
-        </p:txBody>
-      </p:sp>
-      <p:sp>
-        <p:nvSpPr>
-          <p:cNvPr id="11" name="Hito F1"/>
-          <p:cNvSpPr txBox="1"/>
-          <p:nvPr/>
-        </p:nvSpPr>
-        <p:spPr>
-          <a:xfrm>
-            <a:off x="1417320" y="2980944"/>
-            <a:ext cx="5120640" cy="685800"/>
-          </a:xfrm>
-          <a:prstGeom prst="rect">
-            <a:avLst/>
-          </a:prstGeom>
-          <a:noFill/>
-          <a:ln/>
-        </p:spPr>
-        <p:txBody>
-          <a:bodyPr wrap="square" lIns="0" tIns="0" rIns="0" bIns="0" rtlCol="0" anchor="t"/>
-          <a:lstStyle/>
-          <a:p>
-            <a:pPr indent="0" marL="0">
-              <a:buNone/>
-            </a:pPr>
-            <a:r>
-              <a:rPr lang="en-US" sz="1400" dirty="0">
-                <a:solidFill>
-                  <a:schemeClr val="tx2"/>
-                </a:solidFill>
-              </a:rPr>
-              <a:t>Piloto A/B (173 por grupo) y 10 instalaciones con telemetría</a:t>
-            </a:r>
-            <a:endParaRPr lang="en-US" sz="1400" dirty="0"/>
-          </a:p>
-        </p:txBody>
-      </p:sp>
-      <p:sp>
-        <p:nvSpPr>
-          <p:cNvPr id="12" name="Fase F2"/>
-          <p:cNvSpPr/>
-          <p:nvPr/>
-        </p:nvSpPr>
-        <p:spPr>
-          <a:xfrm>
-            <a:off x="548640" y="3840480"/>
-            <a:ext cx="640080" cy="640080"/>
-          </a:xfrm>
-          <a:prstGeom prst="ellipse">
-            <a:avLst/>
-          </a:prstGeom>
-          <a:solidFill>
-            <a:srgbClr val="2B4C9B"/>
-          </a:solidFill>
-          <a:ln w="12700">
-            <a:solidFill>
-              <a:srgbClr val="2B4C9B"/>
-            </a:solidFill>
-            <a:prstDash val="solid"/>
-          </a:ln>
-        </p:spPr>
-      </p:sp>
-      <p:sp>
-        <p:nvSpPr>
-          <p:cNvPr id="13" name="Texto fase F2"/>
-          <p:cNvSpPr txBox="1"/>
-          <p:nvPr/>
-        </p:nvSpPr>
-        <p:spPr>
-          <a:xfrm>
-            <a:off x="548640" y="3840480"/>
-            <a:ext cx="640080" cy="640080"/>
-          </a:xfrm>
-          <a:prstGeom prst="rect">
-            <a:avLst/>
-          </a:prstGeom>
-          <a:noFill/>
-          <a:ln/>
-        </p:spPr>
-        <p:txBody>
-          <a:bodyPr wrap="square" lIns="0" tIns="0" rIns="0" bIns="0" rtlCol="0" anchor="ctr"/>
-          <a:lstStyle/>
-          <a:p>
-            <a:pPr algn="ctr" indent="0" marL="0">
-              <a:buNone/>
-            </a:pPr>
-            <a:r>
-              <a:rPr lang="en-US" sz="1500" b="1" dirty="0">
-                <a:solidFill>
-                  <a:schemeClr val="bg1"/>
-                </a:solidFill>
-              </a:rPr>
-              <a:t>F2</a:t>
-            </a:r>
-            <a:endParaRPr lang="en-US" sz="1500" dirty="0"/>
-          </a:p>
-        </p:txBody>
-      </p:sp>
-      <p:sp>
-        <p:nvSpPr>
-          <p:cNvPr id="14" name="Plazo F2"/>
-          <p:cNvSpPr txBox="1"/>
-          <p:nvPr/>
-        </p:nvSpPr>
-        <p:spPr>
-          <a:xfrm>
-            <a:off x="1417320" y="3822192"/>
-            <a:ext cx="5120640" cy="347472"/>
-          </a:xfrm>
-          <a:prstGeom prst="rect">
-            <a:avLst/>
-          </a:prstGeom>
-          <a:noFill/>
-          <a:ln/>
-        </p:spPr>
-        <p:txBody>
-          <a:bodyPr wrap="square" lIns="0" tIns="0" rIns="0" bIns="0" rtlCol="0" anchor="t"/>
-          <a:lstStyle/>
-          <a:p>
-            <a:pPr indent="0" marL="0">
-              <a:buNone/>
-            </a:pPr>
-            <a:r>
-              <a:rPr lang="en-US" sz="1500" b="1" dirty="0">
-                <a:solidFill>
-                  <a:schemeClr val="accent2"/>
-                </a:solidFill>
-              </a:rPr>
-              <a:t>Meses 4 a 8</a:t>
-            </a:r>
-            <a:endParaRPr lang="en-US" sz="1500" dirty="0"/>
-          </a:p>
-        </p:txBody>
-      </p:sp>
-      <p:sp>
-        <p:nvSpPr>
-          <p:cNvPr id="15" name="Hito F2"/>
-          <p:cNvSpPr txBox="1"/>
-          <p:nvPr/>
-        </p:nvSpPr>
-        <p:spPr>
-          <a:xfrm>
-            <a:off x="1417320" y="4169664"/>
-            <a:ext cx="5120640" cy="685800"/>
-          </a:xfrm>
-          <a:prstGeom prst="rect">
-            <a:avLst/>
-          </a:prstGeom>
-          <a:noFill/>
-          <a:ln/>
-        </p:spPr>
-        <p:txBody>
-          <a:bodyPr wrap="square" lIns="0" tIns="0" rIns="0" bIns="0" rtlCol="0" anchor="t"/>
-          <a:lstStyle/>
-          <a:p>
-            <a:pPr indent="0" marL="0">
-              <a:buNone/>
-            </a:pPr>
-            <a:r>
-              <a:rPr lang="en-US" sz="1400" dirty="0">
-                <a:solidFill>
-                  <a:schemeClr val="tx2"/>
-                </a:solidFill>
-              </a:rPr>
-              <a:t>Verificación posventa y recalibración con datos de Santiago</a:t>
-            </a:r>
-            <a:endParaRPr lang="en-US" sz="1400" dirty="0"/>
-          </a:p>
-        </p:txBody>
-      </p:sp>
-      <p:sp>
-        <p:nvSpPr>
-          <p:cNvPr id="16" name="Fase F3"/>
-          <p:cNvSpPr/>
-          <p:nvPr/>
-        </p:nvSpPr>
-        <p:spPr>
-          <a:xfrm>
-            <a:off x="548640" y="5029200"/>
-            <a:ext cx="640080" cy="640080"/>
-          </a:xfrm>
-          <a:prstGeom prst="ellipse">
-            <a:avLst/>
-          </a:prstGeom>
-          <a:solidFill>
-            <a:srgbClr val="2B4C9B"/>
-          </a:solidFill>
-          <a:ln w="12700">
-            <a:solidFill>
-              <a:srgbClr val="2B4C9B"/>
-            </a:solidFill>
-            <a:prstDash val="solid"/>
-          </a:ln>
-        </p:spPr>
-      </p:sp>
-      <p:sp>
-        <p:nvSpPr>
-          <p:cNvPr id="17" name="Texto fase F3"/>
-          <p:cNvSpPr txBox="1"/>
-          <p:nvPr/>
-        </p:nvSpPr>
-        <p:spPr>
-          <a:xfrm>
-            <a:off x="548640" y="5029200"/>
-            <a:ext cx="640080" cy="640080"/>
-          </a:xfrm>
-          <a:prstGeom prst="rect">
-            <a:avLst/>
-          </a:prstGeom>
-          <a:noFill/>
-          <a:ln/>
-        </p:spPr>
-        <p:txBody>
-          <a:bodyPr wrap="square" lIns="0" tIns="0" rIns="0" bIns="0" rtlCol="0" anchor="ctr"/>
-          <a:lstStyle/>
-          <a:p>
-            <a:pPr algn="ctr" indent="0" marL="0">
-              <a:buNone/>
-            </a:pPr>
-            <a:r>
-              <a:rPr lang="en-US" sz="1500" b="1" dirty="0">
-                <a:solidFill>
-                  <a:schemeClr val="bg1"/>
-                </a:solidFill>
-              </a:rPr>
-              <a:t>F3</a:t>
-            </a:r>
-            <a:endParaRPr lang="en-US" sz="1500" dirty="0"/>
-          </a:p>
-        </p:txBody>
-      </p:sp>
-      <p:sp>
-        <p:nvSpPr>
-          <p:cNvPr id="18" name="Plazo F3"/>
-          <p:cNvSpPr txBox="1"/>
-          <p:nvPr/>
-        </p:nvSpPr>
-        <p:spPr>
-          <a:xfrm>
-            <a:off x="1417320" y="5010912"/>
-            <a:ext cx="5120640" cy="347472"/>
-          </a:xfrm>
-          <a:prstGeom prst="rect">
-            <a:avLst/>
-          </a:prstGeom>
-          <a:noFill/>
-          <a:ln/>
-        </p:spPr>
-        <p:txBody>
-          <a:bodyPr wrap="square" lIns="0" tIns="0" rIns="0" bIns="0" rtlCol="0" anchor="t"/>
-          <a:lstStyle/>
-          <a:p>
-            <a:pPr indent="0" marL="0">
-              <a:buNone/>
-            </a:pPr>
-            <a:r>
-              <a:rPr lang="en-US" sz="1500" b="1" dirty="0">
-                <a:solidFill>
-                  <a:schemeClr val="accent2"/>
-                </a:solidFill>
-              </a:rPr>
-              <a:t>Meses 8 a 12</a:t>
-            </a:r>
-            <a:endParaRPr lang="en-US" sz="1500" dirty="0"/>
-          </a:p>
-        </p:txBody>
-      </p:sp>
-      <p:sp>
-        <p:nvSpPr>
-          <p:cNvPr id="19" name="Hito F3"/>
-          <p:cNvSpPr txBox="1"/>
-          <p:nvPr/>
-        </p:nvSpPr>
-        <p:spPr>
-          <a:xfrm>
-            <a:off x="1417320" y="5358384"/>
-            <a:ext cx="5120640" cy="685800"/>
-          </a:xfrm>
-          <a:prstGeom prst="rect">
-            <a:avLst/>
-          </a:prstGeom>
-          <a:noFill/>
-          <a:ln/>
-        </p:spPr>
-        <p:txBody>
-          <a:bodyPr wrap="square" lIns="0" tIns="0" rIns="0" bIns="0" rtlCol="0" anchor="t"/>
-          <a:lstStyle/>
-          <a:p>
-            <a:pPr indent="0" marL="0">
-              <a:buNone/>
-            </a:pPr>
-            <a:r>
-              <a:rPr lang="en-US" sz="1400" dirty="0">
-                <a:solidFill>
-                  <a:schemeClr val="tx2"/>
-                </a:solidFill>
-              </a:rPr>
-              <a:t>Diagnóstico comercial si la cobertura real queda entre 75% y 85%</a:t>
-            </a:r>
-            <a:endParaRPr lang="en-US" sz="1400" dirty="0"/>
-          </a:p>
-        </p:txBody>
-      </p:sp>
-      <p:sp>
-        <p:nvSpPr>
-          <p:cNvPr id="20" name="Cifra económica 1"/>
-          <p:cNvSpPr/>
-          <p:nvPr/>
-        </p:nvSpPr>
-        <p:spPr>
-          <a:xfrm>
-            <a:off x="6949440" y="1463040"/>
-            <a:ext cx="4663440" cy="1371600"/>
+            <a:ext cx="5440680" cy="2148840"/>
           </a:xfrm>
           <a:prstGeom prst="roundRect">
             <a:avLst>
-              <a:gd name="adj" fmla="val 8000"/>
+              <a:gd name="adj" fmla="val 5106"/>
             </a:avLst>
           </a:prstGeom>
           <a:solidFill>
@@ -9257,14 +9936,63 @@
       </p:sp>
       <p:sp>
         <p:nvSpPr>
-          <p:cNvPr id="21" name="Valor económico 1"/>
+          <p:cNvPr id="4" name="Ícono Privacidad fondo"/>
+          <p:cNvSpPr/>
+          <p:nvPr/>
+        </p:nvSpPr>
+        <p:spPr>
+          <a:xfrm>
+            <a:off x="822960" y="1737360"/>
+            <a:ext cx="777240" cy="777240"/>
+          </a:xfrm>
+          <a:prstGeom prst="ellipse">
+            <a:avLst/>
+          </a:prstGeom>
+          <a:solidFill>
+            <a:srgbClr val="2B4C9B"/>
+          </a:solidFill>
+          <a:ln w="12700">
+            <a:solidFill>
+              <a:srgbClr val="2B4C9B"/>
+            </a:solidFill>
+            <a:prstDash val="solid"/>
+          </a:ln>
+        </p:spPr>
+      </p:sp>
+      <p:pic>
+        <p:nvPicPr>
+          <p:cNvPr id="5" name="Ícono Privacidad" descr="Ícono Privacidad">    </p:cNvPr>
+          <p:cNvPicPr>
+            <a:picLocks noChangeAspect="1"/>
+          </p:cNvPicPr>
+          <p:nvPr/>
+        </p:nvPicPr>
+        <p:blipFill>
+          <a:blip r:embed="rId1"/>
+          <a:stretch>
+            <a:fillRect/>
+          </a:stretch>
+        </p:blipFill>
+        <p:spPr>
+          <a:xfrm>
+            <a:off x="1009498" y="1923898"/>
+            <a:ext cx="404165" cy="404165"/>
+          </a:xfrm>
+          <a:prstGeom prst="rect">
+            <a:avLst/>
+          </a:prstGeom>
+        </p:spPr>
+      </p:pic>
+      <p:sp>
+        <p:nvSpPr>
+          <p:cNvPr id="6" name="Título Privacidad"/>
           <p:cNvSpPr txBox="1"/>
           <p:nvPr/>
         </p:nvSpPr>
         <p:spPr>
           <a:xfrm>
-            <a:off x="7178040" y="1600200"/>
-            <a:ext cx="4206240" cy="594360"/>
+            <a:off x="1828800" y="1810512"/>
+            <a:ext cx="3931920" cy="457200"/>
           </a:xfrm>
           <a:prstGeom prst="rect">
             <a:avLst/>
@@ -9280,27 +10008,27 @@
               <a:buNone/>
             </a:pPr>
             <a:r>
-              <a:rPr lang="en-US" sz="3200" b="1" dirty="0">
-                <a:solidFill>
-                  <a:schemeClr val="accent2"/>
-                </a:solidFill>
-              </a:rPr>
-              <a:t>$9,0 M</a:t>
-            </a:r>
-            <a:endParaRPr lang="en-US" sz="3200" dirty="0"/>
-          </a:p>
-        </p:txBody>
-      </p:sp>
-      <p:sp>
-        <p:nvSpPr>
-          <p:cNvPr id="22" name="Etiqueta económica 1"/>
+              <a:rPr lang="en-US" sz="1800" b="1" dirty="0">
+                <a:solidFill>
+                  <a:schemeClr val="tx2"/>
+                </a:solidFill>
+              </a:rPr>
+              <a:t>Privacidad</a:t>
+            </a:r>
+            <a:endParaRPr lang="en-US" sz="1800" dirty="0"/>
+          </a:p>
+        </p:txBody>
+      </p:sp>
+      <p:sp>
+        <p:nvSpPr>
+          <p:cNvPr id="7" name="Texto Privacidad"/>
           <p:cNvSpPr txBox="1"/>
           <p:nvPr/>
         </p:nvSpPr>
         <p:spPr>
           <a:xfrm>
-            <a:off x="7178040" y="2240280"/>
-            <a:ext cx="4206240" cy="502920"/>
+            <a:off x="822960" y="2606040"/>
+            <a:ext cx="4937760" cy="914400"/>
           </a:xfrm>
           <a:prstGeom prst="rect">
             <a:avLst/>
@@ -9321,7 +10049,7 @@
                   <a:schemeClr val="tx2"/>
                 </a:solidFill>
               </a:rPr>
-              <a:t>costo del estimador el primer año</a:t>
+              <a:t>Consentimiento específico; se recortan 300 m por viaje y se borra la ruta (Ley 21.719). Claude nunca ve ubicación ni datos personales</a:t>
             </a:r>
             <a:endParaRPr lang="en-US" sz="1400" dirty="0"/>
           </a:p>
@@ -9329,18 +10057,328 @@
       </p:sp>
       <p:sp>
         <p:nvSpPr>
-          <p:cNvPr id="23" name="Cifra económica 2"/>
+          <p:cNvPr id="8" name="Responsable 2"/>
           <p:cNvSpPr/>
           <p:nvPr/>
         </p:nvSpPr>
         <p:spPr>
           <a:xfrm>
-            <a:off x="6949440" y="3035808"/>
-            <a:ext cx="4663440" cy="1371600"/>
+            <a:off x="6172200" y="1463040"/>
+            <a:ext cx="5440680" cy="2148840"/>
           </a:xfrm>
           <a:prstGeom prst="roundRect">
             <a:avLst>
-              <a:gd name="adj" fmla="val 8000"/>
+              <a:gd name="adj" fmla="val 5106"/>
+            </a:avLst>
+          </a:prstGeom>
+          <a:solidFill>
+            <a:srgbClr val="EEF3F8"/>
+          </a:solidFill>
+          <a:ln w="12700">
+            <a:solidFill>
+              <a:srgbClr val="EEF3F8"/>
+            </a:solidFill>
+            <a:prstDash val="solid"/>
+          </a:ln>
+          <a:effectLst>
+            <a:outerShdw sx="100000" sy="100000" kx="0" ky="0" algn="bl" rotWithShape="0" blurRad="76200" dist="25400" dir="5400000">
+              <a:srgbClr val="1F2A44">
+                <a:alpha val="12000"/>
+              </a:srgbClr>
+            </a:outerShdw>
+          </a:effectLst>
+        </p:spPr>
+      </p:sp>
+      <p:sp>
+        <p:nvSpPr>
+          <p:cNvPr id="9" name="Ícono Transparencia y equidad fondo"/>
+          <p:cNvSpPr/>
+          <p:nvPr/>
+        </p:nvSpPr>
+        <p:spPr>
+          <a:xfrm>
+            <a:off x="6446520" y="1737360"/>
+            <a:ext cx="777240" cy="777240"/>
+          </a:xfrm>
+          <a:prstGeom prst="ellipse">
+            <a:avLst/>
+          </a:prstGeom>
+          <a:solidFill>
+            <a:srgbClr val="2B4C9B"/>
+          </a:solidFill>
+          <a:ln w="12700">
+            <a:solidFill>
+              <a:srgbClr val="2B4C9B"/>
+            </a:solidFill>
+            <a:prstDash val="solid"/>
+          </a:ln>
+        </p:spPr>
+      </p:sp>
+      <p:pic>
+        <p:nvPicPr>
+          <p:cNvPr id="10" name="Ícono Transparencia y equidad" descr="Ícono Transparencia y equidad">    </p:cNvPr>
+          <p:cNvPicPr>
+            <a:picLocks noChangeAspect="1"/>
+          </p:cNvPicPr>
+          <p:nvPr/>
+        </p:nvPicPr>
+        <p:blipFill>
+          <a:blip r:embed="rId2"/>
+          <a:stretch>
+            <a:fillRect/>
+          </a:stretch>
+        </p:blipFill>
+        <p:spPr>
+          <a:xfrm>
+            <a:off x="6633058" y="1923898"/>
+            <a:ext cx="404165" cy="404165"/>
+          </a:xfrm>
+          <a:prstGeom prst="rect">
+            <a:avLst/>
+          </a:prstGeom>
+        </p:spPr>
+      </p:pic>
+      <p:sp>
+        <p:nvSpPr>
+          <p:cNvPr id="11" name="Título Transparencia y equidad"/>
+          <p:cNvSpPr txBox="1"/>
+          <p:nvPr/>
+        </p:nvSpPr>
+        <p:spPr>
+          <a:xfrm>
+            <a:off x="7452360" y="1810512"/>
+            <a:ext cx="3931920" cy="457200"/>
+          </a:xfrm>
+          <a:prstGeom prst="rect">
+            <a:avLst/>
+          </a:prstGeom>
+          <a:noFill/>
+          <a:ln/>
+        </p:spPr>
+        <p:txBody>
+          <a:bodyPr wrap="square" lIns="0" tIns="0" rIns="0" bIns="0" rtlCol="0" anchor="t"/>
+          <a:lstStyle/>
+          <a:p>
+            <a:pPr indent="0" marL="0">
+              <a:buNone/>
+            </a:pPr>
+            <a:r>
+              <a:rPr lang="en-US" sz="1800" b="1" dirty="0">
+                <a:solidFill>
+                  <a:schemeClr val="tx2"/>
+                </a:solidFill>
+              </a:rPr>
+              <a:t>Transparencia y equidad</a:t>
+            </a:r>
+            <a:endParaRPr lang="en-US" sz="1800" dirty="0"/>
+          </a:p>
+        </p:txBody>
+      </p:sp>
+      <p:sp>
+        <p:nvSpPr>
+          <p:cNvPr id="12" name="Texto Transparencia y equidad"/>
+          <p:cNvSpPr txBox="1"/>
+          <p:nvPr/>
+        </p:nvSpPr>
+        <p:spPr>
+          <a:xfrm>
+            <a:off x="6446520" y="2606040"/>
+            <a:ext cx="4937760" cy="914400"/>
+          </a:xfrm>
+          <a:prstGeom prst="rect">
+            <a:avLst/>
+          </a:prstGeom>
+          <a:noFill/>
+          <a:ln/>
+        </p:spPr>
+        <p:txBody>
+          <a:bodyPr wrap="square" lIns="0" tIns="0" rIns="0" bIns="0" rtlCol="0" anchor="t"/>
+          <a:lstStyle/>
+          <a:p>
+            <a:pPr indent="0" marL="0">
+              <a:buNone/>
+            </a:pPr>
+            <a:r>
+              <a:rPr lang="en-US" sz="1400" dirty="0">
+                <a:solidFill>
+                  <a:schemeClr val="tx2"/>
+                </a:solidFill>
+              </a:rPr>
+              <a:t>Toda cifra va con su rango. La cobertura se mide por perfil: 87% en colectivos frente a 77% en particulares</a:t>
+            </a:r>
+            <a:endParaRPr lang="en-US" sz="1400" dirty="0"/>
+          </a:p>
+        </p:txBody>
+      </p:sp>
+      <p:sp>
+        <p:nvSpPr>
+          <p:cNvPr id="13" name="Responsable 3"/>
+          <p:cNvSpPr/>
+          <p:nvPr/>
+        </p:nvSpPr>
+        <p:spPr>
+          <a:xfrm>
+            <a:off x="548640" y="3840480"/>
+            <a:ext cx="5440680" cy="2148840"/>
+          </a:xfrm>
+          <a:prstGeom prst="roundRect">
+            <a:avLst>
+              <a:gd name="adj" fmla="val 5106"/>
+            </a:avLst>
+          </a:prstGeom>
+          <a:solidFill>
+            <a:srgbClr val="EEF3F8"/>
+          </a:solidFill>
+          <a:ln w="12700">
+            <a:solidFill>
+              <a:srgbClr val="EEF3F8"/>
+            </a:solidFill>
+            <a:prstDash val="solid"/>
+          </a:ln>
+          <a:effectLst>
+            <a:outerShdw sx="100000" sy="100000" kx="0" ky="0" algn="bl" rotWithShape="0" blurRad="76200" dist="25400" dir="5400000">
+              <a:srgbClr val="1F2A44">
+                <a:alpha val="12000"/>
+              </a:srgbClr>
+            </a:outerShdw>
+          </a:effectLst>
+        </p:spPr>
+      </p:sp>
+      <p:sp>
+        <p:nvSpPr>
+          <p:cNvPr id="14" name="Ícono Gobernanza humana fondo"/>
+          <p:cNvSpPr/>
+          <p:nvPr/>
+        </p:nvSpPr>
+        <p:spPr>
+          <a:xfrm>
+            <a:off x="822960" y="4114800"/>
+            <a:ext cx="777240" cy="777240"/>
+          </a:xfrm>
+          <a:prstGeom prst="ellipse">
+            <a:avLst/>
+          </a:prstGeom>
+          <a:solidFill>
+            <a:srgbClr val="2B4C9B"/>
+          </a:solidFill>
+          <a:ln w="12700">
+            <a:solidFill>
+              <a:srgbClr val="2B4C9B"/>
+            </a:solidFill>
+            <a:prstDash val="solid"/>
+          </a:ln>
+        </p:spPr>
+      </p:sp>
+      <p:pic>
+        <p:nvPicPr>
+          <p:cNvPr id="15" name="Ícono Gobernanza humana" descr="Ícono Gobernanza humana">    </p:cNvPr>
+          <p:cNvPicPr>
+            <a:picLocks noChangeAspect="1"/>
+          </p:cNvPicPr>
+          <p:nvPr/>
+        </p:nvPicPr>
+        <p:blipFill>
+          <a:blip r:embed="rId3"/>
+          <a:stretch>
+            <a:fillRect/>
+          </a:stretch>
+        </p:blipFill>
+        <p:spPr>
+          <a:xfrm>
+            <a:off x="1009498" y="4301338"/>
+            <a:ext cx="404165" cy="404165"/>
+          </a:xfrm>
+          <a:prstGeom prst="rect">
+            <a:avLst/>
+          </a:prstGeom>
+        </p:spPr>
+      </p:pic>
+      <p:sp>
+        <p:nvSpPr>
+          <p:cNvPr id="16" name="Título Gobernanza humana"/>
+          <p:cNvSpPr txBox="1"/>
+          <p:nvPr/>
+        </p:nvSpPr>
+        <p:spPr>
+          <a:xfrm>
+            <a:off x="1828800" y="4187952"/>
+            <a:ext cx="3931920" cy="457200"/>
+          </a:xfrm>
+          <a:prstGeom prst="rect">
+            <a:avLst/>
+          </a:prstGeom>
+          <a:noFill/>
+          <a:ln/>
+        </p:spPr>
+        <p:txBody>
+          <a:bodyPr wrap="square" lIns="0" tIns="0" rIns="0" bIns="0" rtlCol="0" anchor="t"/>
+          <a:lstStyle/>
+          <a:p>
+            <a:pPr indent="0" marL="0">
+              <a:buNone/>
+            </a:pPr>
+            <a:r>
+              <a:rPr lang="en-US" sz="1800" b="1" dirty="0">
+                <a:solidFill>
+                  <a:schemeClr val="tx2"/>
+                </a:solidFill>
+              </a:rPr>
+              <a:t>Gobernanza humana</a:t>
+            </a:r>
+            <a:endParaRPr lang="en-US" sz="1800" dirty="0"/>
+          </a:p>
+        </p:txBody>
+      </p:sp>
+      <p:sp>
+        <p:nvSpPr>
+          <p:cNvPr id="17" name="Texto Gobernanza humana"/>
+          <p:cNvSpPr txBox="1"/>
+          <p:nvPr/>
+        </p:nvSpPr>
+        <p:spPr>
+          <a:xfrm>
+            <a:off x="822960" y="4983480"/>
+            <a:ext cx="4937760" cy="914400"/>
+          </a:xfrm>
+          <a:prstGeom prst="rect">
+            <a:avLst/>
+          </a:prstGeom>
+          <a:noFill/>
+          <a:ln/>
+        </p:spPr>
+        <p:txBody>
+          <a:bodyPr wrap="square" lIns="0" tIns="0" rIns="0" bIns="0" rtlCol="0" anchor="t"/>
+          <a:lstStyle/>
+          <a:p>
+            <a:pPr indent="0" marL="0">
+              <a:buNone/>
+            </a:pPr>
+            <a:r>
+              <a:rPr lang="en-US" sz="1400" dirty="0">
+                <a:solidFill>
+                  <a:schemeClr val="tx2"/>
+                </a:solidFill>
+              </a:rPr>
+              <a:t>La gerencia aprueba cambios; el técnico supervisa cada caso; la ingeniería recalibra; nadie delega en la IA legalidad ni garantía</a:t>
+            </a:r>
+            <a:endParaRPr lang="en-US" sz="1400" dirty="0"/>
+          </a:p>
+        </p:txBody>
+      </p:sp>
+      <p:sp>
+        <p:nvSpPr>
+          <p:cNvPr id="18" name="Responsable 4"/>
+          <p:cNvSpPr/>
+          <p:nvPr/>
+        </p:nvSpPr>
+        <p:spPr>
+          <a:xfrm>
+            <a:off x="6172200" y="3840480"/>
+            <a:ext cx="5440680" cy="2148840"/>
+          </a:xfrm>
+          <a:prstGeom prst="roundRect">
+            <a:avLst>
+              <a:gd name="adj" fmla="val 5106"/>
             </a:avLst>
           </a:prstGeom>
           <a:solidFill>
@@ -9363,120 +10401,63 @@
       </p:sp>
       <p:sp>
         <p:nvSpPr>
-          <p:cNvPr id="24" name="Valor económico 2"/>
-          <p:cNvSpPr txBox="1"/>
-          <p:nvPr/>
-        </p:nvSpPr>
-        <p:spPr>
-          <a:xfrm>
-            <a:off x="7178040" y="3172968"/>
-            <a:ext cx="4206240" cy="594360"/>
-          </a:xfrm>
-          <a:prstGeom prst="rect">
-            <a:avLst/>
-          </a:prstGeom>
-          <a:noFill/>
-          <a:ln/>
-        </p:spPr>
-        <p:txBody>
-          <a:bodyPr wrap="square" lIns="0" tIns="0" rIns="0" bIns="0" rtlCol="0" anchor="t"/>
-          <a:lstStyle/>
-          <a:p>
-            <a:pPr indent="0" marL="0">
-              <a:buNone/>
-            </a:pPr>
-            <a:r>
-              <a:rPr lang="en-US" sz="3200" b="1" dirty="0">
-                <a:solidFill>
-                  <a:schemeClr val="accent1"/>
-                </a:solidFill>
-              </a:rPr>
-              <a:t>+3,0 pp</a:t>
-            </a:r>
-            <a:endParaRPr lang="en-US" sz="3200" dirty="0"/>
-          </a:p>
-        </p:txBody>
-      </p:sp>
-      <p:sp>
-        <p:nvSpPr>
-          <p:cNvPr id="25" name="Etiqueta económica 2"/>
-          <p:cNvSpPr txBox="1"/>
-          <p:nvPr/>
-        </p:nvSpPr>
-        <p:spPr>
-          <a:xfrm>
-            <a:off x="7178040" y="3813048"/>
-            <a:ext cx="4206240" cy="502920"/>
-          </a:xfrm>
-          <a:prstGeom prst="rect">
-            <a:avLst/>
-          </a:prstGeom>
-          <a:noFill/>
-          <a:ln/>
-        </p:spPr>
-        <p:txBody>
-          <a:bodyPr wrap="square" lIns="0" tIns="0" rIns="0" bIns="0" rtlCol="0" anchor="t"/>
-          <a:lstStyle/>
-          <a:p>
-            <a:pPr indent="0" marL="0">
-              <a:buNone/>
-            </a:pPr>
-            <a:r>
-              <a:rPr lang="en-US" sz="1400" dirty="0">
-                <a:solidFill>
-                  <a:schemeClr val="bg1"/>
-                </a:solidFill>
-              </a:rPr>
-              <a:t>de agendamiento bastan para pagarlo (H3 plantea +15)</a:t>
-            </a:r>
-            <a:endParaRPr lang="en-US" sz="1400" dirty="0"/>
-          </a:p>
-        </p:txBody>
-      </p:sp>
-      <p:sp>
-        <p:nvSpPr>
-          <p:cNvPr id="26" name="Cifra económica 3"/>
+          <p:cNvPr id="19" name="Ícono Regla de suspensión fondo"/>
           <p:cNvSpPr/>
           <p:nvPr/>
         </p:nvSpPr>
         <p:spPr>
           <a:xfrm>
-            <a:off x="6949440" y="4608576"/>
-            <a:ext cx="4663440" cy="1371600"/>
-          </a:xfrm>
-          <a:prstGeom prst="roundRect">
-            <a:avLst>
-              <a:gd name="adj" fmla="val 8000"/>
-            </a:avLst>
+            <a:off x="6446520" y="4114800"/>
+            <a:ext cx="777240" cy="777240"/>
+          </a:xfrm>
+          <a:prstGeom prst="ellipse">
+            <a:avLst/>
           </a:prstGeom>
           <a:solidFill>
-            <a:srgbClr val="EEF3F8"/>
+            <a:srgbClr val="C0392B"/>
           </a:solidFill>
           <a:ln w="12700">
             <a:solidFill>
-              <a:srgbClr val="EEF3F8"/>
+              <a:srgbClr val="C0392B"/>
             </a:solidFill>
             <a:prstDash val="solid"/>
           </a:ln>
-          <a:effectLst>
-            <a:outerShdw sx="100000" sy="100000" kx="0" ky="0" algn="bl" rotWithShape="0" blurRad="76200" dist="25400" dir="5400000">
-              <a:srgbClr val="1F2A44">
-                <a:alpha val="12000"/>
-              </a:srgbClr>
-            </a:outerShdw>
-          </a:effectLst>
-        </p:spPr>
-      </p:sp>
-      <p:sp>
-        <p:nvSpPr>
-          <p:cNvPr id="27" name="Valor económico 3"/>
+        </p:spPr>
+      </p:sp>
+      <p:pic>
+        <p:nvPicPr>
+          <p:cNvPr id="20" name="Ícono Regla de suspensión" descr="Ícono Regla de suspensión">    </p:cNvPr>
+          <p:cNvPicPr>
+            <a:picLocks noChangeAspect="1"/>
+          </p:cNvPicPr>
+          <p:nvPr/>
+        </p:nvPicPr>
+        <p:blipFill>
+          <a:blip r:embed="rId4"/>
+          <a:stretch>
+            <a:fillRect/>
+          </a:stretch>
+        </p:blipFill>
+        <p:spPr>
+          <a:xfrm>
+            <a:off x="6633058" y="4301338"/>
+            <a:ext cx="404165" cy="404165"/>
+          </a:xfrm>
+          <a:prstGeom prst="rect">
+            <a:avLst/>
+          </a:prstGeom>
+        </p:spPr>
+      </p:pic>
+      <p:sp>
+        <p:nvSpPr>
+          <p:cNvPr id="21" name="Título Regla de suspensión"/>
           <p:cNvSpPr txBox="1"/>
           <p:nvPr/>
         </p:nvSpPr>
         <p:spPr>
           <a:xfrm>
-            <a:off x="7178040" y="4745736"/>
-            <a:ext cx="4206240" cy="594360"/>
+            <a:off x="7452360" y="4187952"/>
+            <a:ext cx="3931920" cy="457200"/>
           </a:xfrm>
           <a:prstGeom prst="rect">
             <a:avLst/>
@@ -9492,27 +10473,27 @@
               <a:buNone/>
             </a:pPr>
             <a:r>
-              <a:rPr lang="en-US" sz="3200" b="1" dirty="0">
-                <a:solidFill>
-                  <a:schemeClr val="accent2"/>
-                </a:solidFill>
-              </a:rPr>
-              <a:t>68%</a:t>
-            </a:r>
-            <a:endParaRPr lang="en-US" sz="3200" dirty="0"/>
-          </a:p>
-        </p:txBody>
-      </p:sp>
-      <p:sp>
-        <p:nvSpPr>
-          <p:cNvPr id="28" name="Etiqueta económica 3"/>
+              <a:rPr lang="en-US" sz="1800" b="1" dirty="0">
+                <a:solidFill>
+                  <a:schemeClr val="bg1"/>
+                </a:solidFill>
+              </a:rPr>
+              <a:t>Regla de suspensión</a:t>
+            </a:r>
+            <a:endParaRPr lang="en-US" sz="1800" dirty="0"/>
+          </a:p>
+        </p:txBody>
+      </p:sp>
+      <p:sp>
+        <p:nvSpPr>
+          <p:cNvPr id="22" name="Texto Regla de suspensión"/>
           <p:cNvSpPr txBox="1"/>
           <p:nvPr/>
         </p:nvSpPr>
         <p:spPr>
           <a:xfrm>
-            <a:off x="7178040" y="5385816"/>
-            <a:ext cx="4206240" cy="502920"/>
+            <a:off x="6446520" y="4983480"/>
+            <a:ext cx="4937760" cy="914400"/>
           </a:xfrm>
           <a:prstGeom prst="rect">
             <a:avLst/>
@@ -9530,10 +10511,10 @@
             <a:r>
               <a:rPr lang="en-US" sz="1400" dirty="0">
                 <a:solidFill>
-                  <a:schemeClr val="tx2"/>
-                </a:solidFill>
-              </a:rPr>
-              <a:t>retorno del año 1 con +5 pp (escenario base)</a:t>
+                  <a:schemeClr val="bg2"/>
+                </a:solidFill>
+              </a:rPr>
+              <a:t>Se detiene si el error real supera 3 pp, la cobertura cae bajo 70%, un perfil queda 15 pp atrás, el validador falla o hay un reclamo fundado</a:t>
             </a:r>
             <a:endParaRPr lang="en-US" sz="1400" dirty="0"/>
           </a:p>

</xml_diff>